<commit_message>
Week 04: Updating previous materials
</commit_message>
<xml_diff>
--- a/Notes/01) Introducing Classes.pptx
+++ b/Notes/01) Introducing Classes.pptx
@@ -4,6 +4,9 @@
   <p:sldMasterIdLst>
     <p:sldMasterId id="2147483672" r:id="rId1"/>
   </p:sldMasterIdLst>
+  <p:notesMasterIdLst>
+    <p:notesMasterId r:id="rId24"/>
+  </p:notesMasterIdLst>
   <p:sldIdLst>
     <p:sldId id="256" r:id="rId2"/>
     <p:sldId id="257" r:id="rId3"/>
@@ -22,9 +25,11 @@
     <p:sldId id="263" r:id="rId16"/>
     <p:sldId id="262" r:id="rId17"/>
     <p:sldId id="264" r:id="rId18"/>
-    <p:sldId id="265" r:id="rId19"/>
-    <p:sldId id="266" r:id="rId20"/>
-    <p:sldId id="267" r:id="rId21"/>
+    <p:sldId id="283" r:id="rId19"/>
+    <p:sldId id="284" r:id="rId20"/>
+    <p:sldId id="265" r:id="rId21"/>
+    <p:sldId id="266" r:id="rId22"/>
+    <p:sldId id="267" r:id="rId23"/>
   </p:sldIdLst>
   <p:sldSz cx="12192000" cy="6858000"/>
   <p:notesSz cx="6858000" cy="9144000"/>
@@ -161,6 +166,8 @@
         <p14:section name="Adding behaviour" id="{671A0207-2174-4593-9D12-70181E75480B}">
           <p14:sldIdLst>
             <p14:sldId id="264"/>
+            <p14:sldId id="283"/>
+            <p14:sldId id="284"/>
             <p14:sldId id="265"/>
             <p14:sldId id="266"/>
             <p14:sldId id="267"/>
@@ -173,6 +180,440 @@
     </p:ext>
   </p:extLst>
 </p:presentation>
+</file>
+
+<file path=ppt/notesMasters/notesMaster1.xml><?xml version="1.0" encoding="utf-8"?>
+<p:notesMaster xmlns:a="http://schemas.openxmlformats.org/drawingml/2006/main" xmlns:r="http://schemas.openxmlformats.org/officeDocument/2006/relationships" xmlns:p="http://schemas.openxmlformats.org/presentationml/2006/main">
+  <p:cSld>
+    <p:bg>
+      <p:bgRef idx="1001">
+        <a:schemeClr val="bg1"/>
+      </p:bgRef>
+    </p:bg>
+    <p:spTree>
+      <p:nvGrpSpPr>
+        <p:cNvPr id="1" name=""/>
+        <p:cNvGrpSpPr/>
+        <p:nvPr/>
+      </p:nvGrpSpPr>
+      <p:grpSpPr>
+        <a:xfrm>
+          <a:off x="0" y="0"/>
+          <a:ext cx="0" cy="0"/>
+          <a:chOff x="0" y="0"/>
+          <a:chExt cx="0" cy="0"/>
+        </a:xfrm>
+      </p:grpSpPr>
+      <p:sp>
+        <p:nvSpPr>
+          <p:cNvPr id="2" name="Header Placeholder 1"/>
+          <p:cNvSpPr>
+            <a:spLocks noGrp="1"/>
+          </p:cNvSpPr>
+          <p:nvPr>
+            <p:ph type="hdr" sz="quarter"/>
+          </p:nvPr>
+        </p:nvSpPr>
+        <p:spPr>
+          <a:xfrm>
+            <a:off x="0" y="0"/>
+            <a:ext cx="2971800" cy="458788"/>
+          </a:xfrm>
+          <a:prstGeom prst="rect">
+            <a:avLst/>
+          </a:prstGeom>
+        </p:spPr>
+        <p:txBody>
+          <a:bodyPr vert="horz" lIns="91440" tIns="45720" rIns="91440" bIns="45720" rtlCol="0"/>
+          <a:lstStyle>
+            <a:lvl1pPr algn="l">
+              <a:defRPr sz="1200"/>
+            </a:lvl1pPr>
+          </a:lstStyle>
+          <a:p>
+            <a:endParaRPr lang="en-IE"/>
+          </a:p>
+        </p:txBody>
+      </p:sp>
+      <p:sp>
+        <p:nvSpPr>
+          <p:cNvPr id="3" name="Date Placeholder 2"/>
+          <p:cNvSpPr>
+            <a:spLocks noGrp="1"/>
+          </p:cNvSpPr>
+          <p:nvPr>
+            <p:ph type="dt" idx="1"/>
+          </p:nvPr>
+        </p:nvSpPr>
+        <p:spPr>
+          <a:xfrm>
+            <a:off x="3884613" y="0"/>
+            <a:ext cx="2971800" cy="458788"/>
+          </a:xfrm>
+          <a:prstGeom prst="rect">
+            <a:avLst/>
+          </a:prstGeom>
+        </p:spPr>
+        <p:txBody>
+          <a:bodyPr vert="horz" lIns="91440" tIns="45720" rIns="91440" bIns="45720" rtlCol="0"/>
+          <a:lstStyle>
+            <a:lvl1pPr algn="r">
+              <a:defRPr sz="1200"/>
+            </a:lvl1pPr>
+          </a:lstStyle>
+          <a:p>
+            <a:fld id="{176547DD-79E8-4ADA-A9F1-F09F551527AF}" type="datetimeFigureOut">
+              <a:rPr lang="en-IE" smtClean="0"/>
+              <a:t>05/10/2026</a:t>
+            </a:fld>
+            <a:endParaRPr lang="en-IE"/>
+          </a:p>
+        </p:txBody>
+      </p:sp>
+      <p:sp>
+        <p:nvSpPr>
+          <p:cNvPr id="4" name="Slide Image Placeholder 3"/>
+          <p:cNvSpPr>
+            <a:spLocks noGrp="1" noRot="1" noChangeAspect="1"/>
+          </p:cNvSpPr>
+          <p:nvPr>
+            <p:ph type="sldImg" idx="2"/>
+          </p:nvPr>
+        </p:nvSpPr>
+        <p:spPr>
+          <a:xfrm>
+            <a:off x="685800" y="1143000"/>
+            <a:ext cx="5486400" cy="3086100"/>
+          </a:xfrm>
+          <a:prstGeom prst="rect">
+            <a:avLst/>
+          </a:prstGeom>
+          <a:noFill/>
+          <a:ln w="12700">
+            <a:solidFill>
+              <a:prstClr val="black"/>
+            </a:solidFill>
+          </a:ln>
+        </p:spPr>
+        <p:txBody>
+          <a:bodyPr vert="horz" lIns="91440" tIns="45720" rIns="91440" bIns="45720" rtlCol="0" anchor="ctr"/>
+          <a:lstStyle/>
+          <a:p>
+            <a:endParaRPr lang="en-IE"/>
+          </a:p>
+        </p:txBody>
+      </p:sp>
+      <p:sp>
+        <p:nvSpPr>
+          <p:cNvPr id="5" name="Notes Placeholder 4"/>
+          <p:cNvSpPr>
+            <a:spLocks noGrp="1"/>
+          </p:cNvSpPr>
+          <p:nvPr>
+            <p:ph type="body" sz="quarter" idx="3"/>
+          </p:nvPr>
+        </p:nvSpPr>
+        <p:spPr>
+          <a:xfrm>
+            <a:off x="685800" y="4400550"/>
+            <a:ext cx="5486400" cy="3600450"/>
+          </a:xfrm>
+          <a:prstGeom prst="rect">
+            <a:avLst/>
+          </a:prstGeom>
+        </p:spPr>
+        <p:txBody>
+          <a:bodyPr vert="horz" lIns="91440" tIns="45720" rIns="91440" bIns="45720" rtlCol="0"/>
+          <a:lstStyle/>
+          <a:p>
+            <a:pPr lvl="0"/>
+            <a:r>
+              <a:rPr lang="en-US"/>
+              <a:t>Click to edit Master text styles</a:t>
+            </a:r>
+          </a:p>
+          <a:p>
+            <a:pPr lvl="1"/>
+            <a:r>
+              <a:rPr lang="en-US"/>
+              <a:t>Second level</a:t>
+            </a:r>
+          </a:p>
+          <a:p>
+            <a:pPr lvl="2"/>
+            <a:r>
+              <a:rPr lang="en-US"/>
+              <a:t>Third level</a:t>
+            </a:r>
+          </a:p>
+          <a:p>
+            <a:pPr lvl="3"/>
+            <a:r>
+              <a:rPr lang="en-US"/>
+              <a:t>Fourth level</a:t>
+            </a:r>
+          </a:p>
+          <a:p>
+            <a:pPr lvl="4"/>
+            <a:r>
+              <a:rPr lang="en-US"/>
+              <a:t>Fifth level</a:t>
+            </a:r>
+            <a:endParaRPr lang="en-IE"/>
+          </a:p>
+        </p:txBody>
+      </p:sp>
+      <p:sp>
+        <p:nvSpPr>
+          <p:cNvPr id="6" name="Footer Placeholder 5"/>
+          <p:cNvSpPr>
+            <a:spLocks noGrp="1"/>
+          </p:cNvSpPr>
+          <p:nvPr>
+            <p:ph type="ftr" sz="quarter" idx="4"/>
+          </p:nvPr>
+        </p:nvSpPr>
+        <p:spPr>
+          <a:xfrm>
+            <a:off x="0" y="8685213"/>
+            <a:ext cx="2971800" cy="458787"/>
+          </a:xfrm>
+          <a:prstGeom prst="rect">
+            <a:avLst/>
+          </a:prstGeom>
+        </p:spPr>
+        <p:txBody>
+          <a:bodyPr vert="horz" lIns="91440" tIns="45720" rIns="91440" bIns="45720" rtlCol="0" anchor="b"/>
+          <a:lstStyle>
+            <a:lvl1pPr algn="l">
+              <a:defRPr sz="1200"/>
+            </a:lvl1pPr>
+          </a:lstStyle>
+          <a:p>
+            <a:endParaRPr lang="en-IE"/>
+          </a:p>
+        </p:txBody>
+      </p:sp>
+      <p:sp>
+        <p:nvSpPr>
+          <p:cNvPr id="7" name="Slide Number Placeholder 6"/>
+          <p:cNvSpPr>
+            <a:spLocks noGrp="1"/>
+          </p:cNvSpPr>
+          <p:nvPr>
+            <p:ph type="sldNum" sz="quarter" idx="5"/>
+          </p:nvPr>
+        </p:nvSpPr>
+        <p:spPr>
+          <a:xfrm>
+            <a:off x="3884613" y="8685213"/>
+            <a:ext cx="2971800" cy="458787"/>
+          </a:xfrm>
+          <a:prstGeom prst="rect">
+            <a:avLst/>
+          </a:prstGeom>
+        </p:spPr>
+        <p:txBody>
+          <a:bodyPr vert="horz" lIns="91440" tIns="45720" rIns="91440" bIns="45720" rtlCol="0" anchor="b"/>
+          <a:lstStyle>
+            <a:lvl1pPr algn="r">
+              <a:defRPr sz="1200"/>
+            </a:lvl1pPr>
+          </a:lstStyle>
+          <a:p>
+            <a:fld id="{C19C3E11-FD7E-4E3D-A557-1CEE681E514B}" type="slidenum">
+              <a:rPr lang="en-IE" smtClean="0"/>
+              <a:t>‹#›</a:t>
+            </a:fld>
+            <a:endParaRPr lang="en-IE"/>
+          </a:p>
+        </p:txBody>
+      </p:sp>
+    </p:spTree>
+    <p:extLst>
+      <p:ext uri="{BB962C8B-B14F-4D97-AF65-F5344CB8AC3E}">
+        <p14:creationId xmlns:p14="http://schemas.microsoft.com/office/powerpoint/2010/main" val="2174035192"/>
+      </p:ext>
+    </p:extLst>
+  </p:cSld>
+  <p:clrMap bg1="lt1" tx1="dk1" bg2="lt2" tx2="dk2" accent1="accent1" accent2="accent2" accent3="accent3" accent4="accent4" accent5="accent5" accent6="accent6" hlink="hlink" folHlink="folHlink"/>
+  <p:notesStyle>
+    <a:lvl1pPr marL="0" algn="l" defTabSz="914400" rtl="0" eaLnBrk="1" latinLnBrk="0" hangingPunct="1">
+      <a:defRPr sz="1200" kern="1200">
+        <a:solidFill>
+          <a:schemeClr val="tx1"/>
+        </a:solidFill>
+        <a:latin typeface="+mn-lt"/>
+        <a:ea typeface="+mn-ea"/>
+        <a:cs typeface="+mn-cs"/>
+      </a:defRPr>
+    </a:lvl1pPr>
+    <a:lvl2pPr marL="457200" algn="l" defTabSz="914400" rtl="0" eaLnBrk="1" latinLnBrk="0" hangingPunct="1">
+      <a:defRPr sz="1200" kern="1200">
+        <a:solidFill>
+          <a:schemeClr val="tx1"/>
+        </a:solidFill>
+        <a:latin typeface="+mn-lt"/>
+        <a:ea typeface="+mn-ea"/>
+        <a:cs typeface="+mn-cs"/>
+      </a:defRPr>
+    </a:lvl2pPr>
+    <a:lvl3pPr marL="914400" algn="l" defTabSz="914400" rtl="0" eaLnBrk="1" latinLnBrk="0" hangingPunct="1">
+      <a:defRPr sz="1200" kern="1200">
+        <a:solidFill>
+          <a:schemeClr val="tx1"/>
+        </a:solidFill>
+        <a:latin typeface="+mn-lt"/>
+        <a:ea typeface="+mn-ea"/>
+        <a:cs typeface="+mn-cs"/>
+      </a:defRPr>
+    </a:lvl3pPr>
+    <a:lvl4pPr marL="1371600" algn="l" defTabSz="914400" rtl="0" eaLnBrk="1" latinLnBrk="0" hangingPunct="1">
+      <a:defRPr sz="1200" kern="1200">
+        <a:solidFill>
+          <a:schemeClr val="tx1"/>
+        </a:solidFill>
+        <a:latin typeface="+mn-lt"/>
+        <a:ea typeface="+mn-ea"/>
+        <a:cs typeface="+mn-cs"/>
+      </a:defRPr>
+    </a:lvl4pPr>
+    <a:lvl5pPr marL="1828800" algn="l" defTabSz="914400" rtl="0" eaLnBrk="1" latinLnBrk="0" hangingPunct="1">
+      <a:defRPr sz="1200" kern="1200">
+        <a:solidFill>
+          <a:schemeClr val="tx1"/>
+        </a:solidFill>
+        <a:latin typeface="+mn-lt"/>
+        <a:ea typeface="+mn-ea"/>
+        <a:cs typeface="+mn-cs"/>
+      </a:defRPr>
+    </a:lvl5pPr>
+    <a:lvl6pPr marL="2286000" algn="l" defTabSz="914400" rtl="0" eaLnBrk="1" latinLnBrk="0" hangingPunct="1">
+      <a:defRPr sz="1200" kern="1200">
+        <a:solidFill>
+          <a:schemeClr val="tx1"/>
+        </a:solidFill>
+        <a:latin typeface="+mn-lt"/>
+        <a:ea typeface="+mn-ea"/>
+        <a:cs typeface="+mn-cs"/>
+      </a:defRPr>
+    </a:lvl6pPr>
+    <a:lvl7pPr marL="2743200" algn="l" defTabSz="914400" rtl="0" eaLnBrk="1" latinLnBrk="0" hangingPunct="1">
+      <a:defRPr sz="1200" kern="1200">
+        <a:solidFill>
+          <a:schemeClr val="tx1"/>
+        </a:solidFill>
+        <a:latin typeface="+mn-lt"/>
+        <a:ea typeface="+mn-ea"/>
+        <a:cs typeface="+mn-cs"/>
+      </a:defRPr>
+    </a:lvl7pPr>
+    <a:lvl8pPr marL="3200400" algn="l" defTabSz="914400" rtl="0" eaLnBrk="1" latinLnBrk="0" hangingPunct="1">
+      <a:defRPr sz="1200" kern="1200">
+        <a:solidFill>
+          <a:schemeClr val="tx1"/>
+        </a:solidFill>
+        <a:latin typeface="+mn-lt"/>
+        <a:ea typeface="+mn-ea"/>
+        <a:cs typeface="+mn-cs"/>
+      </a:defRPr>
+    </a:lvl8pPr>
+    <a:lvl9pPr marL="3657600" algn="l" defTabSz="914400" rtl="0" eaLnBrk="1" latinLnBrk="0" hangingPunct="1">
+      <a:defRPr sz="1200" kern="1200">
+        <a:solidFill>
+          <a:schemeClr val="tx1"/>
+        </a:solidFill>
+        <a:latin typeface="+mn-lt"/>
+        <a:ea typeface="+mn-ea"/>
+        <a:cs typeface="+mn-cs"/>
+      </a:defRPr>
+    </a:lvl9pPr>
+  </p:notesStyle>
+</p:notesMaster>
+</file>
+
+<file path=ppt/notesSlides/notesSlide1.xml><?xml version="1.0" encoding="utf-8"?>
+<p:notes xmlns:a="http://schemas.openxmlformats.org/drawingml/2006/main" xmlns:r="http://schemas.openxmlformats.org/officeDocument/2006/relationships" xmlns:p="http://schemas.openxmlformats.org/presentationml/2006/main">
+  <p:cSld>
+    <p:spTree>
+      <p:nvGrpSpPr>
+        <p:cNvPr id="1" name=""/>
+        <p:cNvGrpSpPr/>
+        <p:nvPr/>
+      </p:nvGrpSpPr>
+      <p:grpSpPr>
+        <a:xfrm>
+          <a:off x="0" y="0"/>
+          <a:ext cx="0" cy="0"/>
+          <a:chOff x="0" y="0"/>
+          <a:chExt cx="0" cy="0"/>
+        </a:xfrm>
+      </p:grpSpPr>
+      <p:sp>
+        <p:nvSpPr>
+          <p:cNvPr id="2" name="Slide Image Placeholder 1"/>
+          <p:cNvSpPr>
+            <a:spLocks noGrp="1" noRot="1" noChangeAspect="1"/>
+          </p:cNvSpPr>
+          <p:nvPr>
+            <p:ph type="sldImg"/>
+          </p:nvPr>
+        </p:nvSpPr>
+        <p:spPr/>
+      </p:sp>
+      <p:sp>
+        <p:nvSpPr>
+          <p:cNvPr id="3" name="Notes Placeholder 2"/>
+          <p:cNvSpPr>
+            <a:spLocks noGrp="1"/>
+          </p:cNvSpPr>
+          <p:nvPr>
+            <p:ph type="body" idx="1"/>
+          </p:nvPr>
+        </p:nvSpPr>
+        <p:spPr/>
+        <p:txBody>
+          <a:bodyPr/>
+          <a:lstStyle/>
+          <a:p>
+            <a:endParaRPr lang="en-IE" dirty="0"/>
+          </a:p>
+        </p:txBody>
+      </p:sp>
+      <p:sp>
+        <p:nvSpPr>
+          <p:cNvPr id="4" name="Slide Number Placeholder 3"/>
+          <p:cNvSpPr>
+            <a:spLocks noGrp="1"/>
+          </p:cNvSpPr>
+          <p:nvPr>
+            <p:ph type="sldNum" sz="quarter" idx="5"/>
+          </p:nvPr>
+        </p:nvSpPr>
+        <p:spPr/>
+        <p:txBody>
+          <a:bodyPr/>
+          <a:lstStyle/>
+          <a:p>
+            <a:fld id="{C19C3E11-FD7E-4E3D-A557-1CEE681E514B}" type="slidenum">
+              <a:rPr lang="en-IE" smtClean="0"/>
+              <a:t>15</a:t>
+            </a:fld>
+            <a:endParaRPr lang="en-IE"/>
+          </a:p>
+        </p:txBody>
+      </p:sp>
+    </p:spTree>
+    <p:extLst>
+      <p:ext uri="{BB962C8B-B14F-4D97-AF65-F5344CB8AC3E}">
+        <p14:creationId xmlns:p14="http://schemas.microsoft.com/office/powerpoint/2010/main" val="146493212"/>
+      </p:ext>
+    </p:extLst>
+  </p:cSld>
+  <p:clrMapOvr>
+    <a:masterClrMapping/>
+  </p:clrMapOvr>
+</p:notes>
 </file>
 
 <file path=ppt/slideLayouts/slideLayout1.xml><?xml version="1.0" encoding="utf-8"?>
@@ -415,7 +856,7 @@
           <a:p>
             <a:fld id="{0FEC7C34-F4EF-4F0A-B9AE-A8DDABF3D064}" type="datetimeFigureOut">
               <a:rPr lang="en-IE" smtClean="0"/>
-              <a:t>23/09/2026</a:t>
+              <a:t>05/10/2026</a:t>
             </a:fld>
             <a:endParaRPr lang="en-IE"/>
           </a:p>
@@ -623,7 +1064,7 @@
           <a:p>
             <a:fld id="{0FEC7C34-F4EF-4F0A-B9AE-A8DDABF3D064}" type="datetimeFigureOut">
               <a:rPr lang="en-IE" smtClean="0"/>
-              <a:t>23/09/2026</a:t>
+              <a:t>05/10/2026</a:t>
             </a:fld>
             <a:endParaRPr lang="en-IE"/>
           </a:p>
@@ -879,7 +1320,7 @@
           <a:p>
             <a:fld id="{0FEC7C34-F4EF-4F0A-B9AE-A8DDABF3D064}" type="datetimeFigureOut">
               <a:rPr lang="en-IE" smtClean="0"/>
-              <a:t>23/09/2026</a:t>
+              <a:t>05/10/2026</a:t>
             </a:fld>
             <a:endParaRPr lang="en-IE"/>
           </a:p>
@@ -1049,7 +1490,7 @@
           <a:p>
             <a:fld id="{0FEC7C34-F4EF-4F0A-B9AE-A8DDABF3D064}" type="datetimeFigureOut">
               <a:rPr lang="en-IE" smtClean="0"/>
-              <a:t>23/09/2026</a:t>
+              <a:t>05/10/2026</a:t>
             </a:fld>
             <a:endParaRPr lang="en-IE"/>
           </a:p>
@@ -1392,7 +1833,7 @@
           <a:p>
             <a:fld id="{0FEC7C34-F4EF-4F0A-B9AE-A8DDABF3D064}" type="datetimeFigureOut">
               <a:rPr lang="en-IE" smtClean="0"/>
-              <a:t>23/09/2026</a:t>
+              <a:t>05/10/2026</a:t>
             </a:fld>
             <a:endParaRPr lang="en-IE"/>
           </a:p>
@@ -1667,7 +2108,7 @@
           <a:p>
             <a:fld id="{0FEC7C34-F4EF-4F0A-B9AE-A8DDABF3D064}" type="datetimeFigureOut">
               <a:rPr lang="en-IE" smtClean="0"/>
-              <a:t>23/09/2026</a:t>
+              <a:t>05/10/2026</a:t>
             </a:fld>
             <a:endParaRPr lang="en-IE"/>
           </a:p>
@@ -2046,7 +2487,7 @@
           <a:p>
             <a:fld id="{0FEC7C34-F4EF-4F0A-B9AE-A8DDABF3D064}" type="datetimeFigureOut">
               <a:rPr lang="en-IE" smtClean="0"/>
-              <a:t>23/09/2026</a:t>
+              <a:t>05/10/2026</a:t>
             </a:fld>
             <a:endParaRPr lang="en-IE"/>
           </a:p>
@@ -2164,7 +2605,7 @@
           <a:p>
             <a:fld id="{0FEC7C34-F4EF-4F0A-B9AE-A8DDABF3D064}" type="datetimeFigureOut">
               <a:rPr lang="en-IE" smtClean="0"/>
-              <a:t>23/09/2026</a:t>
+              <a:t>05/10/2026</a:t>
             </a:fld>
             <a:endParaRPr lang="en-IE"/>
           </a:p>
@@ -2335,7 +2776,7 @@
           <a:p>
             <a:fld id="{0FEC7C34-F4EF-4F0A-B9AE-A8DDABF3D064}" type="datetimeFigureOut">
               <a:rPr lang="en-IE" smtClean="0"/>
-              <a:t>23/09/2026</a:t>
+              <a:t>05/10/2026</a:t>
             </a:fld>
             <a:endParaRPr lang="en-IE"/>
           </a:p>
@@ -2689,7 +3130,7 @@
           <a:p>
             <a:fld id="{0FEC7C34-F4EF-4F0A-B9AE-A8DDABF3D064}" type="datetimeFigureOut">
               <a:rPr lang="en-IE" smtClean="0"/>
-              <a:t>23/09/2026</a:t>
+              <a:t>05/10/2026</a:t>
             </a:fld>
             <a:endParaRPr lang="en-IE"/>
           </a:p>
@@ -3066,7 +3507,7 @@
           <a:p>
             <a:fld id="{0FEC7C34-F4EF-4F0A-B9AE-A8DDABF3D064}" type="datetimeFigureOut">
               <a:rPr lang="en-IE" smtClean="0"/>
-              <a:t>23/09/2026</a:t>
+              <a:t>05/10/2026</a:t>
             </a:fld>
             <a:endParaRPr lang="en-IE"/>
           </a:p>
@@ -3367,7 +3808,7 @@
           <a:p>
             <a:fld id="{0FEC7C34-F4EF-4F0A-B9AE-A8DDABF3D064}" type="datetimeFigureOut">
               <a:rPr lang="en-IE" smtClean="0"/>
-              <a:t>23/09/2026</a:t>
+              <a:t>05/10/2026</a:t>
             </a:fld>
             <a:endParaRPr lang="en-IE"/>
           </a:p>
@@ -5192,8 +5633,8 @@
         </p:nvSpPr>
         <p:spPr>
           <a:xfrm>
-            <a:off x="6937705" y="6234873"/>
-            <a:ext cx="5124092" cy="541451"/>
+            <a:off x="6797615" y="6234873"/>
+            <a:ext cx="5264182" cy="541451"/>
           </a:xfrm>
           <a:prstGeom prst="roundRect">
             <a:avLst/>
@@ -5225,7 +5666,15 @@
             </a:r>
             <a:r>
               <a:rPr lang="en-IE" sz="1700" dirty="0" err="1"/>
-              <a:t>slide_examples.introducing_classes</a:t>
+              <a:t>slide_examples</a:t>
+            </a:r>
+            <a:r>
+              <a:rPr lang="en-IE" sz="1700" dirty="0"/>
+              <a:t>/</a:t>
+            </a:r>
+            <a:r>
+              <a:rPr lang="en-IE" sz="1700" dirty="0" err="1"/>
+              <a:t>introducing_classes</a:t>
             </a:r>
             <a:r>
               <a:rPr lang="en-IE" sz="1700" dirty="0"/>
@@ -5645,7 +6094,7 @@
         <p:spPr>
           <a:xfrm>
             <a:off x="63260" y="5937197"/>
-            <a:ext cx="5610143" cy="541451"/>
+            <a:ext cx="5727940" cy="541451"/>
           </a:xfrm>
           <a:prstGeom prst="roundRect">
             <a:avLst/>
@@ -5677,7 +6126,15 @@
             </a:r>
             <a:r>
               <a:rPr lang="en-IE" sz="1700" dirty="0" err="1"/>
-              <a:t>slide_examples.introducing_classes</a:t>
+              <a:t>slide_examples</a:t>
+            </a:r>
+            <a:r>
+              <a:rPr lang="en-IE" sz="1700" dirty="0"/>
+              <a:t>/</a:t>
+            </a:r>
+            <a:r>
+              <a:rPr lang="en-IE" sz="1700" dirty="0" err="1"/>
+              <a:t>introducing_classes</a:t>
             </a:r>
             <a:r>
               <a:rPr lang="en-IE" sz="1700" dirty="0"/>
@@ -5701,7 +6158,7 @@
           <p:nvPr/>
         </p:nvPicPr>
         <p:blipFill>
-          <a:blip r:embed="rId2"/>
+          <a:blip r:embed="rId3"/>
           <a:stretch>
             <a:fillRect/>
           </a:stretch>
@@ -6298,7 +6755,15 @@
           <a:p>
             <a:r>
               <a:rPr lang="en-IE" sz="1700" dirty="0" err="1"/>
-              <a:t>slide_examples.introducing_classes</a:t>
+              <a:t>slide_examples</a:t>
+            </a:r>
+            <a:r>
+              <a:rPr lang="en-IE" sz="1700" dirty="0"/>
+              <a:t>/</a:t>
+            </a:r>
+            <a:r>
+              <a:rPr lang="en-IE" sz="1700" dirty="0" err="1"/>
+              <a:t>introducing_classes</a:t>
             </a:r>
             <a:r>
               <a:rPr lang="en-IE" sz="1700" dirty="0"/>
@@ -6600,6 +7065,2058 @@
           <p:cNvPr id="2" name="Title 1">
             <a:extLst>
               <a:ext uri="{FF2B5EF4-FFF2-40B4-BE49-F238E27FC236}">
+                <a16:creationId xmlns:a16="http://schemas.microsoft.com/office/drawing/2014/main" id="{48C4962E-1673-6E2D-1425-C9D5B27CB638}"/>
+              </a:ext>
+            </a:extLst>
+          </p:cNvPr>
+          <p:cNvSpPr>
+            <a:spLocks noGrp="1"/>
+          </p:cNvSpPr>
+          <p:nvPr>
+            <p:ph type="title"/>
+          </p:nvPr>
+        </p:nvSpPr>
+        <p:spPr/>
+        <p:txBody>
+          <a:bodyPr/>
+          <a:lstStyle/>
+          <a:p>
+            <a:r>
+              <a:rPr lang="en-IE" dirty="0"/>
+              <a:t>When We Use static</a:t>
+            </a:r>
+          </a:p>
+        </p:txBody>
+      </p:sp>
+      <p:sp>
+        <p:nvSpPr>
+          <p:cNvPr id="3" name="Content Placeholder 2">
+            <a:extLst>
+              <a:ext uri="{FF2B5EF4-FFF2-40B4-BE49-F238E27FC236}">
+                <a16:creationId xmlns:a16="http://schemas.microsoft.com/office/drawing/2014/main" id="{ADD49BA2-DF00-D07B-0513-CFF3809A6EB9}"/>
+              </a:ext>
+            </a:extLst>
+          </p:cNvPr>
+          <p:cNvSpPr>
+            <a:spLocks noGrp="1"/>
+          </p:cNvSpPr>
+          <p:nvPr>
+            <p:ph idx="1"/>
+          </p:nvPr>
+        </p:nvSpPr>
+        <p:spPr/>
+        <p:txBody>
+          <a:bodyPr>
+            <a:normAutofit/>
+          </a:bodyPr>
+          <a:lstStyle/>
+          <a:p>
+            <a:pPr lvl="1"/>
+            <a:r>
+              <a:rPr lang="en-IE" sz="3600" dirty="0"/>
+              <a:t>static makes things shared</a:t>
+            </a:r>
+          </a:p>
+          <a:p>
+            <a:pPr lvl="2"/>
+            <a:r>
+              <a:rPr lang="en-IE" sz="2800" dirty="0"/>
+              <a:t>Each object shares a SINGLE copy</a:t>
+            </a:r>
+          </a:p>
+        </p:txBody>
+      </p:sp>
+      <p:grpSp>
+        <p:nvGrpSpPr>
+          <p:cNvPr id="14" name="Group 13">
+            <a:extLst>
+              <a:ext uri="{FF2B5EF4-FFF2-40B4-BE49-F238E27FC236}">
+                <a16:creationId xmlns:a16="http://schemas.microsoft.com/office/drawing/2014/main" id="{014CAED0-D8AC-A39D-278A-D579B0A9997D}"/>
+              </a:ext>
+            </a:extLst>
+          </p:cNvPr>
+          <p:cNvGrpSpPr/>
+          <p:nvPr/>
+        </p:nvGrpSpPr>
+        <p:grpSpPr>
+          <a:xfrm>
+            <a:off x="668896" y="3485701"/>
+            <a:ext cx="3685461" cy="2937390"/>
+            <a:chOff x="668896" y="3485701"/>
+            <a:chExt cx="3685461" cy="2937390"/>
+          </a:xfrm>
+        </p:grpSpPr>
+        <p:grpSp>
+          <p:nvGrpSpPr>
+            <p:cNvPr id="9" name="Group 8">
+              <a:extLst>
+                <a:ext uri="{FF2B5EF4-FFF2-40B4-BE49-F238E27FC236}">
+                  <a16:creationId xmlns:a16="http://schemas.microsoft.com/office/drawing/2014/main" id="{72E25BFF-5600-FE29-060D-4A51F0432E99}"/>
+                </a:ext>
+              </a:extLst>
+            </p:cNvPr>
+            <p:cNvGrpSpPr/>
+            <p:nvPr/>
+          </p:nvGrpSpPr>
+          <p:grpSpPr>
+            <a:xfrm>
+              <a:off x="668896" y="3485701"/>
+              <a:ext cx="3604053" cy="1017281"/>
+              <a:chOff x="668896" y="4187323"/>
+              <a:chExt cx="3604053" cy="1017281"/>
+            </a:xfrm>
+          </p:grpSpPr>
+          <p:grpSp>
+            <p:nvGrpSpPr>
+              <p:cNvPr id="6" name="Group 5">
+                <a:extLst>
+                  <a:ext uri="{FF2B5EF4-FFF2-40B4-BE49-F238E27FC236}">
+                    <a16:creationId xmlns:a16="http://schemas.microsoft.com/office/drawing/2014/main" id="{CFC65755-972B-8100-4C59-97A274DA6C49}"/>
+                  </a:ext>
+                </a:extLst>
+              </p:cNvPr>
+              <p:cNvGrpSpPr/>
+              <p:nvPr/>
+            </p:nvGrpSpPr>
+            <p:grpSpPr>
+              <a:xfrm>
+                <a:off x="668896" y="4187323"/>
+                <a:ext cx="3604053" cy="1017281"/>
+                <a:chOff x="668896" y="4187323"/>
+                <a:chExt cx="3604053" cy="1017281"/>
+              </a:xfrm>
+            </p:grpSpPr>
+            <p:sp>
+              <p:nvSpPr>
+                <p:cNvPr id="4" name="Rectangle: Rounded Corners 3">
+                  <a:extLst>
+                    <a:ext uri="{FF2B5EF4-FFF2-40B4-BE49-F238E27FC236}">
+                      <a16:creationId xmlns:a16="http://schemas.microsoft.com/office/drawing/2014/main" id="{3411830B-60C0-C1DD-EA85-353C2F7D25C4}"/>
+                    </a:ext>
+                  </a:extLst>
+                </p:cNvPr>
+                <p:cNvSpPr/>
+                <p:nvPr/>
+              </p:nvSpPr>
+              <p:spPr>
+                <a:xfrm>
+                  <a:off x="1892058" y="4187323"/>
+                  <a:ext cx="2380891" cy="1017281"/>
+                </a:xfrm>
+                <a:prstGeom prst="roundRect">
+                  <a:avLst/>
+                </a:prstGeom>
+                <a:noFill/>
+              </p:spPr>
+              <p:style>
+                <a:lnRef idx="2">
+                  <a:schemeClr val="accent1">
+                    <a:shade val="15000"/>
+                  </a:schemeClr>
+                </a:lnRef>
+                <a:fillRef idx="1">
+                  <a:schemeClr val="accent1"/>
+                </a:fillRef>
+                <a:effectRef idx="0">
+                  <a:schemeClr val="accent1"/>
+                </a:effectRef>
+                <a:fontRef idx="minor">
+                  <a:schemeClr val="lt1"/>
+                </a:fontRef>
+              </p:style>
+              <p:txBody>
+                <a:bodyPr rtlCol="0" anchor="ctr"/>
+                <a:lstStyle/>
+                <a:p>
+                  <a:r>
+                    <a:rPr lang="en-IE" dirty="0" err="1">
+                      <a:solidFill>
+                        <a:schemeClr val="tx1">
+                          <a:lumMod val="75000"/>
+                          <a:lumOff val="25000"/>
+                        </a:schemeClr>
+                      </a:solidFill>
+                    </a:rPr>
+                    <a:t>windowType</a:t>
+                  </a:r>
+                  <a:r>
+                    <a:rPr lang="en-IE" dirty="0">
+                      <a:solidFill>
+                        <a:schemeClr val="tx1">
+                          <a:lumMod val="75000"/>
+                          <a:lumOff val="25000"/>
+                        </a:schemeClr>
+                      </a:solidFill>
+                    </a:rPr>
+                    <a:t> = “Bay”</a:t>
+                  </a:r>
+                </a:p>
+                <a:p>
+                  <a:r>
+                    <a:rPr lang="en-IE" dirty="0" err="1">
+                      <a:solidFill>
+                        <a:schemeClr val="tx1">
+                          <a:lumMod val="75000"/>
+                          <a:lumOff val="25000"/>
+                        </a:schemeClr>
+                      </a:solidFill>
+                    </a:rPr>
+                    <a:t>numRooms</a:t>
+                  </a:r>
+                  <a:r>
+                    <a:rPr lang="en-IE" dirty="0">
+                      <a:solidFill>
+                        <a:schemeClr val="tx1">
+                          <a:lumMod val="75000"/>
+                          <a:lumOff val="25000"/>
+                        </a:schemeClr>
+                      </a:solidFill>
+                    </a:rPr>
+                    <a:t>  = 20 </a:t>
+                  </a:r>
+                </a:p>
+                <a:p>
+                  <a:r>
+                    <a:rPr lang="en-IE" dirty="0">
+                      <a:solidFill>
+                        <a:schemeClr val="tx1">
+                          <a:lumMod val="75000"/>
+                          <a:lumOff val="25000"/>
+                        </a:schemeClr>
+                      </a:solidFill>
+                    </a:rPr>
+                    <a:t>colour  = “Blue”</a:t>
+                  </a:r>
+                </a:p>
+              </p:txBody>
+            </p:sp>
+            <p:sp>
+              <p:nvSpPr>
+                <p:cNvPr id="5" name="TextBox 4">
+                  <a:extLst>
+                    <a:ext uri="{FF2B5EF4-FFF2-40B4-BE49-F238E27FC236}">
+                      <a16:creationId xmlns:a16="http://schemas.microsoft.com/office/drawing/2014/main" id="{0EFFBC4D-54B7-A516-55EC-BF4CDCF1BCC2}"/>
+                    </a:ext>
+                  </a:extLst>
+                </p:cNvPr>
+                <p:cNvSpPr txBox="1"/>
+                <p:nvPr/>
+              </p:nvSpPr>
+              <p:spPr>
+                <a:xfrm>
+                  <a:off x="668896" y="4364966"/>
+                  <a:ext cx="872355" cy="369332"/>
+                </a:xfrm>
+                <a:prstGeom prst="rect">
+                  <a:avLst/>
+                </a:prstGeom>
+                <a:noFill/>
+              </p:spPr>
+              <p:txBody>
+                <a:bodyPr wrap="none" rtlCol="0">
+                  <a:spAutoFit/>
+                </a:bodyPr>
+                <a:lstStyle/>
+                <a:p>
+                  <a:r>
+                    <a:rPr lang="en-IE" dirty="0"/>
+                    <a:t>house1</a:t>
+                  </a:r>
+                </a:p>
+              </p:txBody>
+            </p:sp>
+          </p:grpSp>
+          <p:cxnSp>
+            <p:nvCxnSpPr>
+              <p:cNvPr id="8" name="Straight Arrow Connector 7">
+                <a:extLst>
+                  <a:ext uri="{FF2B5EF4-FFF2-40B4-BE49-F238E27FC236}">
+                    <a16:creationId xmlns:a16="http://schemas.microsoft.com/office/drawing/2014/main" id="{0F18E929-07AD-59AA-35A4-E4DEA4D5AD28}"/>
+                  </a:ext>
+                </a:extLst>
+              </p:cNvPr>
+              <p:cNvCxnSpPr>
+                <a:stCxn id="5" idx="3"/>
+              </p:cNvCxnSpPr>
+              <p:nvPr/>
+            </p:nvCxnSpPr>
+            <p:spPr>
+              <a:xfrm flipV="1">
+                <a:off x="1541251" y="4520242"/>
+                <a:ext cx="350807" cy="29390"/>
+              </a:xfrm>
+              <a:prstGeom prst="straightConnector1">
+                <a:avLst/>
+              </a:prstGeom>
+              <a:ln>
+                <a:tailEnd type="triangle"/>
+              </a:ln>
+            </p:spPr>
+            <p:style>
+              <a:lnRef idx="1">
+                <a:schemeClr val="accent1"/>
+              </a:lnRef>
+              <a:fillRef idx="0">
+                <a:schemeClr val="accent1"/>
+              </a:fillRef>
+              <a:effectRef idx="0">
+                <a:schemeClr val="accent1"/>
+              </a:effectRef>
+              <a:fontRef idx="minor">
+                <a:schemeClr val="tx1"/>
+              </a:fontRef>
+            </p:style>
+          </p:cxnSp>
+        </p:grpSp>
+        <p:sp>
+          <p:nvSpPr>
+            <p:cNvPr id="10" name="TextBox 9">
+              <a:extLst>
+                <a:ext uri="{FF2B5EF4-FFF2-40B4-BE49-F238E27FC236}">
+                  <a16:creationId xmlns:a16="http://schemas.microsoft.com/office/drawing/2014/main" id="{D96BA3BC-FE20-AAA8-2CE7-47F4EF21AC50}"/>
+                </a:ext>
+              </a:extLst>
+            </p:cNvPr>
+            <p:cNvSpPr txBox="1"/>
+            <p:nvPr/>
+          </p:nvSpPr>
+          <p:spPr>
+            <a:xfrm>
+              <a:off x="1329362" y="4668765"/>
+              <a:ext cx="3024995" cy="1754326"/>
+            </a:xfrm>
+            <a:prstGeom prst="rect">
+              <a:avLst/>
+            </a:prstGeom>
+            <a:noFill/>
+          </p:spPr>
+          <p:txBody>
+            <a:bodyPr wrap="square" rtlCol="0">
+              <a:spAutoFit/>
+            </a:bodyPr>
+            <a:lstStyle/>
+            <a:p>
+              <a:r>
+                <a:rPr lang="en-IE" dirty="0"/>
+                <a:t>House house1 = new House();</a:t>
+              </a:r>
+            </a:p>
+            <a:p>
+              <a:r>
+                <a:rPr lang="en-IE" dirty="0"/>
+                <a:t>house1.windowType = “Bay”</a:t>
+              </a:r>
+            </a:p>
+            <a:p>
+              <a:r>
+                <a:rPr lang="en-IE" dirty="0"/>
+                <a:t>house1.numRooms = 20</a:t>
+              </a:r>
+            </a:p>
+            <a:p>
+              <a:r>
+                <a:rPr lang="en-IE" dirty="0"/>
+                <a:t>house1.colour = “Blue”</a:t>
+              </a:r>
+            </a:p>
+            <a:p>
+              <a:endParaRPr lang="en-IE" dirty="0"/>
+            </a:p>
+            <a:p>
+              <a:r>
+                <a:rPr lang="en-IE" dirty="0"/>
+                <a:t>house1.display()</a:t>
+              </a:r>
+            </a:p>
+          </p:txBody>
+        </p:sp>
+      </p:grpSp>
+      <p:sp>
+        <p:nvSpPr>
+          <p:cNvPr id="12" name="Rectangle: Rounded Corners 11">
+            <a:extLst>
+              <a:ext uri="{FF2B5EF4-FFF2-40B4-BE49-F238E27FC236}">
+                <a16:creationId xmlns:a16="http://schemas.microsoft.com/office/drawing/2014/main" id="{25FF286E-DDA2-ACDE-E67B-380D785BAEF7}"/>
+              </a:ext>
+            </a:extLst>
+          </p:cNvPr>
+          <p:cNvSpPr/>
+          <p:nvPr/>
+        </p:nvSpPr>
+        <p:spPr>
+          <a:xfrm>
+            <a:off x="4701333" y="3145759"/>
+            <a:ext cx="2688630" cy="1063932"/>
+          </a:xfrm>
+          <a:prstGeom prst="roundRect">
+            <a:avLst/>
+          </a:prstGeom>
+          <a:noFill/>
+        </p:spPr>
+        <p:style>
+          <a:lnRef idx="2">
+            <a:schemeClr val="accent1">
+              <a:shade val="15000"/>
+            </a:schemeClr>
+          </a:lnRef>
+          <a:fillRef idx="1">
+            <a:schemeClr val="accent1"/>
+          </a:fillRef>
+          <a:effectRef idx="0">
+            <a:schemeClr val="accent1"/>
+          </a:effectRef>
+          <a:fontRef idx="minor">
+            <a:schemeClr val="lt1"/>
+          </a:fontRef>
+        </p:style>
+        <p:txBody>
+          <a:bodyPr rtlCol="0" anchor="ctr"/>
+          <a:lstStyle/>
+          <a:p>
+            <a:pPr algn="ctr"/>
+            <a:r>
+              <a:rPr lang="en-IE" sz="1600" b="1" dirty="0">
+                <a:solidFill>
+                  <a:schemeClr val="tx1">
+                    <a:lumMod val="75000"/>
+                    <a:lumOff val="25000"/>
+                  </a:schemeClr>
+                </a:solidFill>
+              </a:rPr>
+              <a:t>House:</a:t>
+            </a:r>
+          </a:p>
+          <a:p>
+            <a:endParaRPr lang="en-IE" sz="1000" dirty="0">
+              <a:solidFill>
+                <a:schemeClr val="tx1">
+                  <a:lumMod val="75000"/>
+                  <a:lumOff val="25000"/>
+                </a:schemeClr>
+              </a:solidFill>
+            </a:endParaRPr>
+          </a:p>
+          <a:p>
+            <a:r>
+              <a:rPr lang="en-IE" sz="1600" dirty="0">
+                <a:solidFill>
+                  <a:schemeClr val="tx1">
+                    <a:lumMod val="75000"/>
+                    <a:lumOff val="25000"/>
+                  </a:schemeClr>
+                </a:solidFill>
+                <a:latin typeface="Consolas" panose="020B0609020204030204" pitchFamily="49" charset="0"/>
+              </a:rPr>
+              <a:t>public </a:t>
+            </a:r>
+            <a:r>
+              <a:rPr lang="en-IE" sz="1600" b="1" dirty="0">
+                <a:solidFill>
+                  <a:schemeClr val="tx1">
+                    <a:lumMod val="75000"/>
+                    <a:lumOff val="25000"/>
+                  </a:schemeClr>
+                </a:solidFill>
+                <a:latin typeface="Consolas" panose="020B0609020204030204" pitchFamily="49" charset="0"/>
+              </a:rPr>
+              <a:t>static</a:t>
+            </a:r>
+            <a:r>
+              <a:rPr lang="en-IE" sz="1600" dirty="0">
+                <a:solidFill>
+                  <a:schemeClr val="tx1">
+                    <a:lumMod val="75000"/>
+                    <a:lumOff val="25000"/>
+                  </a:schemeClr>
+                </a:solidFill>
+                <a:latin typeface="Consolas" panose="020B0609020204030204" pitchFamily="49" charset="0"/>
+              </a:rPr>
+              <a:t> void display()</a:t>
+            </a:r>
+          </a:p>
+        </p:txBody>
+      </p:sp>
+      <p:grpSp>
+        <p:nvGrpSpPr>
+          <p:cNvPr id="15" name="Group 14">
+            <a:extLst>
+              <a:ext uri="{FF2B5EF4-FFF2-40B4-BE49-F238E27FC236}">
+                <a16:creationId xmlns:a16="http://schemas.microsoft.com/office/drawing/2014/main" id="{DB8059AF-BD95-02FD-75D3-407442F612D5}"/>
+              </a:ext>
+            </a:extLst>
+          </p:cNvPr>
+          <p:cNvGrpSpPr/>
+          <p:nvPr/>
+        </p:nvGrpSpPr>
+        <p:grpSpPr>
+          <a:xfrm>
+            <a:off x="7630354" y="3480759"/>
+            <a:ext cx="3892750" cy="2937390"/>
+            <a:chOff x="893185" y="3485701"/>
+            <a:chExt cx="3892750" cy="2937390"/>
+          </a:xfrm>
+        </p:grpSpPr>
+        <p:grpSp>
+          <p:nvGrpSpPr>
+            <p:cNvPr id="16" name="Group 15">
+              <a:extLst>
+                <a:ext uri="{FF2B5EF4-FFF2-40B4-BE49-F238E27FC236}">
+                  <a16:creationId xmlns:a16="http://schemas.microsoft.com/office/drawing/2014/main" id="{E1C95E03-86DE-F3B4-F2A3-7FF1133996ED}"/>
+                </a:ext>
+              </a:extLst>
+            </p:cNvPr>
+            <p:cNvGrpSpPr/>
+            <p:nvPr/>
+          </p:nvGrpSpPr>
+          <p:grpSpPr>
+            <a:xfrm>
+              <a:off x="893185" y="3485701"/>
+              <a:ext cx="3812237" cy="1017281"/>
+              <a:chOff x="893185" y="4187323"/>
+              <a:chExt cx="3812237" cy="1017281"/>
+            </a:xfrm>
+          </p:grpSpPr>
+          <p:grpSp>
+            <p:nvGrpSpPr>
+              <p:cNvPr id="18" name="Group 17">
+                <a:extLst>
+                  <a:ext uri="{FF2B5EF4-FFF2-40B4-BE49-F238E27FC236}">
+                    <a16:creationId xmlns:a16="http://schemas.microsoft.com/office/drawing/2014/main" id="{1473BB09-1F43-DE4F-FEEC-B82779965A91}"/>
+                  </a:ext>
+                </a:extLst>
+              </p:cNvPr>
+              <p:cNvGrpSpPr/>
+              <p:nvPr/>
+            </p:nvGrpSpPr>
+            <p:grpSpPr>
+              <a:xfrm>
+                <a:off x="893185" y="4187323"/>
+                <a:ext cx="3812237" cy="1017281"/>
+                <a:chOff x="893185" y="4187323"/>
+                <a:chExt cx="3812237" cy="1017281"/>
+              </a:xfrm>
+            </p:grpSpPr>
+            <p:sp>
+              <p:nvSpPr>
+                <p:cNvPr id="20" name="Rectangle: Rounded Corners 19">
+                  <a:extLst>
+                    <a:ext uri="{FF2B5EF4-FFF2-40B4-BE49-F238E27FC236}">
+                      <a16:creationId xmlns:a16="http://schemas.microsoft.com/office/drawing/2014/main" id="{C25666B4-EC95-1B49-48D5-C9FB6131DB1C}"/>
+                    </a:ext>
+                  </a:extLst>
+                </p:cNvPr>
+                <p:cNvSpPr/>
+                <p:nvPr/>
+              </p:nvSpPr>
+              <p:spPr>
+                <a:xfrm>
+                  <a:off x="2116347" y="4187323"/>
+                  <a:ext cx="2589075" cy="1017281"/>
+                </a:xfrm>
+                <a:prstGeom prst="roundRect">
+                  <a:avLst/>
+                </a:prstGeom>
+                <a:noFill/>
+              </p:spPr>
+              <p:style>
+                <a:lnRef idx="2">
+                  <a:schemeClr val="accent1">
+                    <a:shade val="15000"/>
+                  </a:schemeClr>
+                </a:lnRef>
+                <a:fillRef idx="1">
+                  <a:schemeClr val="accent1"/>
+                </a:fillRef>
+                <a:effectRef idx="0">
+                  <a:schemeClr val="accent1"/>
+                </a:effectRef>
+                <a:fontRef idx="minor">
+                  <a:schemeClr val="lt1"/>
+                </a:fontRef>
+              </p:style>
+              <p:txBody>
+                <a:bodyPr rtlCol="0" anchor="ctr"/>
+                <a:lstStyle/>
+                <a:p>
+                  <a:r>
+                    <a:rPr lang="en-IE" dirty="0" err="1">
+                      <a:solidFill>
+                        <a:schemeClr val="tx1">
+                          <a:lumMod val="75000"/>
+                          <a:lumOff val="25000"/>
+                        </a:schemeClr>
+                      </a:solidFill>
+                    </a:rPr>
+                    <a:t>windowType</a:t>
+                  </a:r>
+                  <a:r>
+                    <a:rPr lang="en-IE" dirty="0">
+                      <a:solidFill>
+                        <a:schemeClr val="tx1">
+                          <a:lumMod val="75000"/>
+                          <a:lumOff val="25000"/>
+                        </a:schemeClr>
+                      </a:solidFill>
+                    </a:rPr>
+                    <a:t> = “Picture”</a:t>
+                  </a:r>
+                </a:p>
+                <a:p>
+                  <a:r>
+                    <a:rPr lang="en-IE" dirty="0" err="1">
+                      <a:solidFill>
+                        <a:schemeClr val="tx1">
+                          <a:lumMod val="75000"/>
+                          <a:lumOff val="25000"/>
+                        </a:schemeClr>
+                      </a:solidFill>
+                    </a:rPr>
+                    <a:t>numRooms</a:t>
+                  </a:r>
+                  <a:r>
+                    <a:rPr lang="en-IE" dirty="0">
+                      <a:solidFill>
+                        <a:schemeClr val="tx1">
+                          <a:lumMod val="75000"/>
+                          <a:lumOff val="25000"/>
+                        </a:schemeClr>
+                      </a:solidFill>
+                    </a:rPr>
+                    <a:t>  = 10 </a:t>
+                  </a:r>
+                </a:p>
+                <a:p>
+                  <a:r>
+                    <a:rPr lang="en-IE" dirty="0">
+                      <a:solidFill>
+                        <a:schemeClr val="tx1">
+                          <a:lumMod val="75000"/>
+                          <a:lumOff val="25000"/>
+                        </a:schemeClr>
+                      </a:solidFill>
+                    </a:rPr>
+                    <a:t>colour  = “Orange”</a:t>
+                  </a:r>
+                </a:p>
+              </p:txBody>
+            </p:sp>
+            <p:sp>
+              <p:nvSpPr>
+                <p:cNvPr id="21" name="TextBox 20">
+                  <a:extLst>
+                    <a:ext uri="{FF2B5EF4-FFF2-40B4-BE49-F238E27FC236}">
+                      <a16:creationId xmlns:a16="http://schemas.microsoft.com/office/drawing/2014/main" id="{8A9ADB39-E9D5-027F-09FB-D86FA09A2700}"/>
+                    </a:ext>
+                  </a:extLst>
+                </p:cNvPr>
+                <p:cNvSpPr txBox="1"/>
+                <p:nvPr/>
+              </p:nvSpPr>
+              <p:spPr>
+                <a:xfrm>
+                  <a:off x="893185" y="4364966"/>
+                  <a:ext cx="872355" cy="369332"/>
+                </a:xfrm>
+                <a:prstGeom prst="rect">
+                  <a:avLst/>
+                </a:prstGeom>
+                <a:noFill/>
+              </p:spPr>
+              <p:txBody>
+                <a:bodyPr wrap="none" rtlCol="0">
+                  <a:spAutoFit/>
+                </a:bodyPr>
+                <a:lstStyle/>
+                <a:p>
+                  <a:r>
+                    <a:rPr lang="en-IE" dirty="0"/>
+                    <a:t>house2</a:t>
+                  </a:r>
+                </a:p>
+              </p:txBody>
+            </p:sp>
+          </p:grpSp>
+          <p:cxnSp>
+            <p:nvCxnSpPr>
+              <p:cNvPr id="19" name="Straight Arrow Connector 18">
+                <a:extLst>
+                  <a:ext uri="{FF2B5EF4-FFF2-40B4-BE49-F238E27FC236}">
+                    <a16:creationId xmlns:a16="http://schemas.microsoft.com/office/drawing/2014/main" id="{F822BCC5-1CC3-5264-F999-21ACF5BF2C27}"/>
+                  </a:ext>
+                </a:extLst>
+              </p:cNvPr>
+              <p:cNvCxnSpPr>
+                <a:stCxn id="21" idx="3"/>
+              </p:cNvCxnSpPr>
+              <p:nvPr/>
+            </p:nvCxnSpPr>
+            <p:spPr>
+              <a:xfrm flipV="1">
+                <a:off x="1765540" y="4520242"/>
+                <a:ext cx="350807" cy="29390"/>
+              </a:xfrm>
+              <a:prstGeom prst="straightConnector1">
+                <a:avLst/>
+              </a:prstGeom>
+              <a:ln>
+                <a:tailEnd type="triangle"/>
+              </a:ln>
+            </p:spPr>
+            <p:style>
+              <a:lnRef idx="1">
+                <a:schemeClr val="accent1"/>
+              </a:lnRef>
+              <a:fillRef idx="0">
+                <a:schemeClr val="accent1"/>
+              </a:fillRef>
+              <a:effectRef idx="0">
+                <a:schemeClr val="accent1"/>
+              </a:effectRef>
+              <a:fontRef idx="minor">
+                <a:schemeClr val="tx1"/>
+              </a:fontRef>
+            </p:style>
+          </p:cxnSp>
+        </p:grpSp>
+        <p:sp>
+          <p:nvSpPr>
+            <p:cNvPr id="17" name="TextBox 16">
+              <a:extLst>
+                <a:ext uri="{FF2B5EF4-FFF2-40B4-BE49-F238E27FC236}">
+                  <a16:creationId xmlns:a16="http://schemas.microsoft.com/office/drawing/2014/main" id="{4CCCD028-A352-3CE1-5D83-442A64D3BBAE}"/>
+                </a:ext>
+              </a:extLst>
+            </p:cNvPr>
+            <p:cNvSpPr txBox="1"/>
+            <p:nvPr/>
+          </p:nvSpPr>
+          <p:spPr>
+            <a:xfrm>
+              <a:off x="1329362" y="4668765"/>
+              <a:ext cx="3456573" cy="1754326"/>
+            </a:xfrm>
+            <a:prstGeom prst="rect">
+              <a:avLst/>
+            </a:prstGeom>
+            <a:noFill/>
+          </p:spPr>
+          <p:txBody>
+            <a:bodyPr wrap="square" rtlCol="0">
+              <a:spAutoFit/>
+            </a:bodyPr>
+            <a:lstStyle/>
+            <a:p>
+              <a:r>
+                <a:rPr lang="en-IE" dirty="0"/>
+                <a:t>House house2 = new House();</a:t>
+              </a:r>
+            </a:p>
+            <a:p>
+              <a:r>
+                <a:rPr lang="en-IE" dirty="0"/>
+                <a:t>house2.windowType = “Picture”</a:t>
+              </a:r>
+            </a:p>
+            <a:p>
+              <a:r>
+                <a:rPr lang="en-IE" dirty="0"/>
+                <a:t>house2.numRooms = 10</a:t>
+              </a:r>
+            </a:p>
+            <a:p>
+              <a:r>
+                <a:rPr lang="en-IE" dirty="0"/>
+                <a:t>house2.colour = “Orange”</a:t>
+              </a:r>
+            </a:p>
+            <a:p>
+              <a:endParaRPr lang="en-IE" dirty="0"/>
+            </a:p>
+            <a:p>
+              <a:r>
+                <a:rPr lang="en-IE" dirty="0"/>
+                <a:t>house2.display()</a:t>
+              </a:r>
+            </a:p>
+          </p:txBody>
+        </p:sp>
+      </p:grpSp>
+      <p:cxnSp>
+        <p:nvCxnSpPr>
+          <p:cNvPr id="23" name="Connector: Elbow 22">
+            <a:extLst>
+              <a:ext uri="{FF2B5EF4-FFF2-40B4-BE49-F238E27FC236}">
+                <a16:creationId xmlns:a16="http://schemas.microsoft.com/office/drawing/2014/main" id="{BF35212D-2A3D-84D8-AB6C-789BC48D5293}"/>
+              </a:ext>
+            </a:extLst>
+          </p:cNvPr>
+          <p:cNvCxnSpPr>
+            <a:cxnSpLocks/>
+            <a:endCxn id="12" idx="2"/>
+          </p:cNvCxnSpPr>
+          <p:nvPr/>
+        </p:nvCxnSpPr>
+        <p:spPr>
+          <a:xfrm flipV="1">
+            <a:off x="3044357" y="4209691"/>
+            <a:ext cx="3001291" cy="2053086"/>
+          </a:xfrm>
+          <a:prstGeom prst="bentConnector2">
+            <a:avLst/>
+          </a:prstGeom>
+          <a:ln>
+            <a:tailEnd type="triangle"/>
+          </a:ln>
+        </p:spPr>
+        <p:style>
+          <a:lnRef idx="1">
+            <a:schemeClr val="accent1"/>
+          </a:lnRef>
+          <a:fillRef idx="0">
+            <a:schemeClr val="accent1"/>
+          </a:fillRef>
+          <a:effectRef idx="0">
+            <a:schemeClr val="accent1"/>
+          </a:effectRef>
+          <a:fontRef idx="minor">
+            <a:schemeClr val="tx1"/>
+          </a:fontRef>
+        </p:style>
+      </p:cxnSp>
+      <p:cxnSp>
+        <p:nvCxnSpPr>
+          <p:cNvPr id="25" name="Connector: Elbow 24">
+            <a:extLst>
+              <a:ext uri="{FF2B5EF4-FFF2-40B4-BE49-F238E27FC236}">
+                <a16:creationId xmlns:a16="http://schemas.microsoft.com/office/drawing/2014/main" id="{CCC34E3F-DBF6-444E-3E24-790B544EDB66}"/>
+              </a:ext>
+            </a:extLst>
+          </p:cNvPr>
+          <p:cNvCxnSpPr>
+            <a:cxnSpLocks/>
+            <a:endCxn id="12" idx="2"/>
+          </p:cNvCxnSpPr>
+          <p:nvPr/>
+        </p:nvCxnSpPr>
+        <p:spPr>
+          <a:xfrm rot="10800000">
+            <a:off x="6045648" y="4209691"/>
+            <a:ext cx="2074684" cy="2053086"/>
+          </a:xfrm>
+          <a:prstGeom prst="bentConnector2">
+            <a:avLst/>
+          </a:prstGeom>
+          <a:ln>
+            <a:tailEnd type="triangle"/>
+          </a:ln>
+        </p:spPr>
+        <p:style>
+          <a:lnRef idx="1">
+            <a:schemeClr val="accent1"/>
+          </a:lnRef>
+          <a:fillRef idx="0">
+            <a:schemeClr val="accent1"/>
+          </a:fillRef>
+          <a:effectRef idx="0">
+            <a:schemeClr val="accent1"/>
+          </a:effectRef>
+          <a:fontRef idx="minor">
+            <a:schemeClr val="tx1"/>
+          </a:fontRef>
+        </p:style>
+      </p:cxnSp>
+    </p:spTree>
+    <p:extLst>
+      <p:ext uri="{BB962C8B-B14F-4D97-AF65-F5344CB8AC3E}">
+        <p14:creationId xmlns:p14="http://schemas.microsoft.com/office/powerpoint/2010/main" val="1194318144"/>
+      </p:ext>
+    </p:extLst>
+  </p:cSld>
+  <p:clrMapOvr>
+    <a:masterClrMapping/>
+  </p:clrMapOvr>
+</p:sld>
+</file>
+
+<file path=ppt/slides/slide19.xml><?xml version="1.0" encoding="utf-8"?>
+<p:sld xmlns:a="http://schemas.openxmlformats.org/drawingml/2006/main" xmlns:r="http://schemas.openxmlformats.org/officeDocument/2006/relationships" xmlns:p="http://schemas.openxmlformats.org/presentationml/2006/main">
+  <p:cSld>
+    <p:spTree>
+      <p:nvGrpSpPr>
+        <p:cNvPr id="1" name="">
+          <a:extLst>
+            <a:ext uri="{FF2B5EF4-FFF2-40B4-BE49-F238E27FC236}">
+              <a16:creationId xmlns:a16="http://schemas.microsoft.com/office/drawing/2014/main" id="{F797C7EC-11F9-E3E2-7DB5-31295A007940}"/>
+            </a:ext>
+          </a:extLst>
+        </p:cNvPr>
+        <p:cNvGrpSpPr/>
+        <p:nvPr/>
+      </p:nvGrpSpPr>
+      <p:grpSpPr>
+        <a:xfrm>
+          <a:off x="0" y="0"/>
+          <a:ext cx="0" cy="0"/>
+          <a:chOff x="0" y="0"/>
+          <a:chExt cx="0" cy="0"/>
+        </a:xfrm>
+      </p:grpSpPr>
+      <p:sp>
+        <p:nvSpPr>
+          <p:cNvPr id="2" name="Title 1">
+            <a:extLst>
+              <a:ext uri="{FF2B5EF4-FFF2-40B4-BE49-F238E27FC236}">
+                <a16:creationId xmlns:a16="http://schemas.microsoft.com/office/drawing/2014/main" id="{43FC2EA2-580D-984F-BE5A-A219B7EB2AB9}"/>
+              </a:ext>
+            </a:extLst>
+          </p:cNvPr>
+          <p:cNvSpPr>
+            <a:spLocks noGrp="1"/>
+          </p:cNvSpPr>
+          <p:nvPr>
+            <p:ph type="title"/>
+          </p:nvPr>
+        </p:nvSpPr>
+        <p:spPr/>
+        <p:txBody>
+          <a:bodyPr/>
+          <a:lstStyle/>
+          <a:p>
+            <a:r>
+              <a:rPr lang="en-IE" dirty="0"/>
+              <a:t>When We DON’T Use static</a:t>
+            </a:r>
+          </a:p>
+        </p:txBody>
+      </p:sp>
+      <p:sp>
+        <p:nvSpPr>
+          <p:cNvPr id="3" name="Content Placeholder 2">
+            <a:extLst>
+              <a:ext uri="{FF2B5EF4-FFF2-40B4-BE49-F238E27FC236}">
+                <a16:creationId xmlns:a16="http://schemas.microsoft.com/office/drawing/2014/main" id="{95655F3D-2BBF-C10C-43A6-D08630DC59C8}"/>
+              </a:ext>
+            </a:extLst>
+          </p:cNvPr>
+          <p:cNvSpPr>
+            <a:spLocks noGrp="1"/>
+          </p:cNvSpPr>
+          <p:nvPr>
+            <p:ph idx="1"/>
+          </p:nvPr>
+        </p:nvSpPr>
+        <p:spPr/>
+        <p:txBody>
+          <a:bodyPr>
+            <a:normAutofit/>
+          </a:bodyPr>
+          <a:lstStyle/>
+          <a:p>
+            <a:pPr lvl="1"/>
+            <a:r>
+              <a:rPr lang="en-IE" sz="3600" dirty="0"/>
+              <a:t>Leaving out static makes an </a:t>
+            </a:r>
+            <a:r>
+              <a:rPr lang="en-IE" sz="3600" i="1" dirty="0"/>
+              <a:t>instance</a:t>
+            </a:r>
+            <a:r>
+              <a:rPr lang="en-IE" sz="3600" dirty="0"/>
+              <a:t> method</a:t>
+            </a:r>
+          </a:p>
+          <a:p>
+            <a:pPr lvl="2"/>
+            <a:r>
+              <a:rPr lang="en-IE" sz="2800" dirty="0"/>
+              <a:t>Each object has its OWN copy</a:t>
+            </a:r>
+          </a:p>
+        </p:txBody>
+      </p:sp>
+      <p:grpSp>
+        <p:nvGrpSpPr>
+          <p:cNvPr id="14" name="Group 13">
+            <a:extLst>
+              <a:ext uri="{FF2B5EF4-FFF2-40B4-BE49-F238E27FC236}">
+                <a16:creationId xmlns:a16="http://schemas.microsoft.com/office/drawing/2014/main" id="{59563856-E64D-9B5C-84BD-8946FD5CE8A4}"/>
+              </a:ext>
+            </a:extLst>
+          </p:cNvPr>
+          <p:cNvGrpSpPr/>
+          <p:nvPr/>
+        </p:nvGrpSpPr>
+        <p:grpSpPr>
+          <a:xfrm>
+            <a:off x="668896" y="2927231"/>
+            <a:ext cx="4309627" cy="3495860"/>
+            <a:chOff x="668896" y="2927231"/>
+            <a:chExt cx="4309627" cy="3495860"/>
+          </a:xfrm>
+        </p:grpSpPr>
+        <p:grpSp>
+          <p:nvGrpSpPr>
+            <p:cNvPr id="9" name="Group 8">
+              <a:extLst>
+                <a:ext uri="{FF2B5EF4-FFF2-40B4-BE49-F238E27FC236}">
+                  <a16:creationId xmlns:a16="http://schemas.microsoft.com/office/drawing/2014/main" id="{71C6665B-FA94-326A-39BC-8DC97A30D3D7}"/>
+                </a:ext>
+              </a:extLst>
+            </p:cNvPr>
+            <p:cNvGrpSpPr/>
+            <p:nvPr/>
+          </p:nvGrpSpPr>
+          <p:grpSpPr>
+            <a:xfrm>
+              <a:off x="668896" y="2927231"/>
+              <a:ext cx="4309627" cy="1736592"/>
+              <a:chOff x="668896" y="3628853"/>
+              <a:chExt cx="4309627" cy="1736592"/>
+            </a:xfrm>
+          </p:grpSpPr>
+          <p:grpSp>
+            <p:nvGrpSpPr>
+              <p:cNvPr id="6" name="Group 5">
+                <a:extLst>
+                  <a:ext uri="{FF2B5EF4-FFF2-40B4-BE49-F238E27FC236}">
+                    <a16:creationId xmlns:a16="http://schemas.microsoft.com/office/drawing/2014/main" id="{1E5CB1C6-3741-6D96-3333-730941780BB4}"/>
+                  </a:ext>
+                </a:extLst>
+              </p:cNvPr>
+              <p:cNvGrpSpPr/>
+              <p:nvPr/>
+            </p:nvGrpSpPr>
+            <p:grpSpPr>
+              <a:xfrm>
+                <a:off x="668896" y="3628853"/>
+                <a:ext cx="4309627" cy="1736592"/>
+                <a:chOff x="668896" y="3628853"/>
+                <a:chExt cx="4309627" cy="1736592"/>
+              </a:xfrm>
+            </p:grpSpPr>
+            <p:sp>
+              <p:nvSpPr>
+                <p:cNvPr id="4" name="Rectangle: Rounded Corners 3">
+                  <a:extLst>
+                    <a:ext uri="{FF2B5EF4-FFF2-40B4-BE49-F238E27FC236}">
+                      <a16:creationId xmlns:a16="http://schemas.microsoft.com/office/drawing/2014/main" id="{2BDCDDCE-33CE-4281-33A8-455A435158A6}"/>
+                    </a:ext>
+                  </a:extLst>
+                </p:cNvPr>
+                <p:cNvSpPr/>
+                <p:nvPr/>
+              </p:nvSpPr>
+              <p:spPr>
+                <a:xfrm>
+                  <a:off x="1892058" y="3628853"/>
+                  <a:ext cx="3086465" cy="1736592"/>
+                </a:xfrm>
+                <a:prstGeom prst="roundRect">
+                  <a:avLst/>
+                </a:prstGeom>
+                <a:noFill/>
+              </p:spPr>
+              <p:style>
+                <a:lnRef idx="2">
+                  <a:schemeClr val="accent1">
+                    <a:shade val="15000"/>
+                  </a:schemeClr>
+                </a:lnRef>
+                <a:fillRef idx="1">
+                  <a:schemeClr val="accent1"/>
+                </a:fillRef>
+                <a:effectRef idx="0">
+                  <a:schemeClr val="accent1"/>
+                </a:effectRef>
+                <a:fontRef idx="minor">
+                  <a:schemeClr val="lt1"/>
+                </a:fontRef>
+              </p:style>
+              <p:txBody>
+                <a:bodyPr rtlCol="0" anchor="ctr"/>
+                <a:lstStyle/>
+                <a:p>
+                  <a:r>
+                    <a:rPr lang="en-IE" dirty="0" err="1">
+                      <a:solidFill>
+                        <a:schemeClr val="tx1">
+                          <a:lumMod val="75000"/>
+                          <a:lumOff val="25000"/>
+                        </a:schemeClr>
+                      </a:solidFill>
+                    </a:rPr>
+                    <a:t>windowType</a:t>
+                  </a:r>
+                  <a:r>
+                    <a:rPr lang="en-IE" dirty="0">
+                      <a:solidFill>
+                        <a:schemeClr val="tx1">
+                          <a:lumMod val="75000"/>
+                          <a:lumOff val="25000"/>
+                        </a:schemeClr>
+                      </a:solidFill>
+                    </a:rPr>
+                    <a:t> = “Bay”</a:t>
+                  </a:r>
+                </a:p>
+                <a:p>
+                  <a:r>
+                    <a:rPr lang="en-IE" dirty="0" err="1">
+                      <a:solidFill>
+                        <a:schemeClr val="tx1">
+                          <a:lumMod val="75000"/>
+                          <a:lumOff val="25000"/>
+                        </a:schemeClr>
+                      </a:solidFill>
+                    </a:rPr>
+                    <a:t>numRooms</a:t>
+                  </a:r>
+                  <a:r>
+                    <a:rPr lang="en-IE" dirty="0">
+                      <a:solidFill>
+                        <a:schemeClr val="tx1">
+                          <a:lumMod val="75000"/>
+                          <a:lumOff val="25000"/>
+                        </a:schemeClr>
+                      </a:solidFill>
+                    </a:rPr>
+                    <a:t>  = 20 </a:t>
+                  </a:r>
+                </a:p>
+                <a:p>
+                  <a:r>
+                    <a:rPr lang="en-IE" dirty="0">
+                      <a:solidFill>
+                        <a:schemeClr val="tx1">
+                          <a:lumMod val="75000"/>
+                          <a:lumOff val="25000"/>
+                        </a:schemeClr>
+                      </a:solidFill>
+                    </a:rPr>
+                    <a:t>colour  = “Blue”</a:t>
+                  </a:r>
+                </a:p>
+                <a:p>
+                  <a:endParaRPr lang="en-IE" dirty="0">
+                    <a:solidFill>
+                      <a:schemeClr val="tx1">
+                        <a:lumMod val="75000"/>
+                        <a:lumOff val="25000"/>
+                      </a:schemeClr>
+                    </a:solidFill>
+                  </a:endParaRPr>
+                </a:p>
+                <a:p>
+                  <a:r>
+                    <a:rPr lang="en-IE" dirty="0">
+                      <a:solidFill>
+                        <a:schemeClr val="accent2"/>
+                      </a:solidFill>
+                      <a:latin typeface="Consolas" panose="020B0609020204030204" pitchFamily="49" charset="0"/>
+                    </a:rPr>
+                    <a:t>public void display(</a:t>
+                  </a:r>
+                  <a:r>
+                    <a:rPr lang="en-IE" dirty="0">
+                      <a:solidFill>
+                        <a:schemeClr val="tx1">
+                          <a:lumMod val="75000"/>
+                          <a:lumOff val="25000"/>
+                        </a:schemeClr>
+                      </a:solidFill>
+                      <a:latin typeface="Consolas" panose="020B0609020204030204" pitchFamily="49" charset="0"/>
+                    </a:rPr>
+                    <a:t>)</a:t>
+                  </a:r>
+                </a:p>
+              </p:txBody>
+            </p:sp>
+            <p:sp>
+              <p:nvSpPr>
+                <p:cNvPr id="5" name="TextBox 4">
+                  <a:extLst>
+                    <a:ext uri="{FF2B5EF4-FFF2-40B4-BE49-F238E27FC236}">
+                      <a16:creationId xmlns:a16="http://schemas.microsoft.com/office/drawing/2014/main" id="{73B53E4C-7537-143D-28BC-07AA65255288}"/>
+                    </a:ext>
+                  </a:extLst>
+                </p:cNvPr>
+                <p:cNvSpPr txBox="1"/>
+                <p:nvPr/>
+              </p:nvSpPr>
+              <p:spPr>
+                <a:xfrm>
+                  <a:off x="668896" y="4364966"/>
+                  <a:ext cx="872355" cy="369332"/>
+                </a:xfrm>
+                <a:prstGeom prst="rect">
+                  <a:avLst/>
+                </a:prstGeom>
+                <a:noFill/>
+              </p:spPr>
+              <p:txBody>
+                <a:bodyPr wrap="none" rtlCol="0">
+                  <a:spAutoFit/>
+                </a:bodyPr>
+                <a:lstStyle/>
+                <a:p>
+                  <a:r>
+                    <a:rPr lang="en-IE" dirty="0"/>
+                    <a:t>house1</a:t>
+                  </a:r>
+                </a:p>
+              </p:txBody>
+            </p:sp>
+          </p:grpSp>
+          <p:cxnSp>
+            <p:nvCxnSpPr>
+              <p:cNvPr id="8" name="Straight Arrow Connector 7">
+                <a:extLst>
+                  <a:ext uri="{FF2B5EF4-FFF2-40B4-BE49-F238E27FC236}">
+                    <a16:creationId xmlns:a16="http://schemas.microsoft.com/office/drawing/2014/main" id="{4C696D0F-0010-217D-A937-FD44B517E2CE}"/>
+                  </a:ext>
+                </a:extLst>
+              </p:cNvPr>
+              <p:cNvCxnSpPr>
+                <a:stCxn id="5" idx="3"/>
+              </p:cNvCxnSpPr>
+              <p:nvPr/>
+            </p:nvCxnSpPr>
+            <p:spPr>
+              <a:xfrm flipV="1">
+                <a:off x="1541251" y="4520242"/>
+                <a:ext cx="350807" cy="29390"/>
+              </a:xfrm>
+              <a:prstGeom prst="straightConnector1">
+                <a:avLst/>
+              </a:prstGeom>
+              <a:ln>
+                <a:tailEnd type="triangle"/>
+              </a:ln>
+            </p:spPr>
+            <p:style>
+              <a:lnRef idx="1">
+                <a:schemeClr val="accent1"/>
+              </a:lnRef>
+              <a:fillRef idx="0">
+                <a:schemeClr val="accent1"/>
+              </a:fillRef>
+              <a:effectRef idx="0">
+                <a:schemeClr val="accent1"/>
+              </a:effectRef>
+              <a:fontRef idx="minor">
+                <a:schemeClr val="tx1"/>
+              </a:fontRef>
+            </p:style>
+          </p:cxnSp>
+        </p:grpSp>
+        <p:sp>
+          <p:nvSpPr>
+            <p:cNvPr id="10" name="TextBox 9">
+              <a:extLst>
+                <a:ext uri="{FF2B5EF4-FFF2-40B4-BE49-F238E27FC236}">
+                  <a16:creationId xmlns:a16="http://schemas.microsoft.com/office/drawing/2014/main" id="{6C158337-1CC3-F879-19B2-29F205D4A156}"/>
+                </a:ext>
+              </a:extLst>
+            </p:cNvPr>
+            <p:cNvSpPr txBox="1"/>
+            <p:nvPr/>
+          </p:nvSpPr>
+          <p:spPr>
+            <a:xfrm>
+              <a:off x="1329362" y="4668765"/>
+              <a:ext cx="3024995" cy="1754326"/>
+            </a:xfrm>
+            <a:prstGeom prst="rect">
+              <a:avLst/>
+            </a:prstGeom>
+            <a:noFill/>
+          </p:spPr>
+          <p:txBody>
+            <a:bodyPr wrap="square" rtlCol="0">
+              <a:spAutoFit/>
+            </a:bodyPr>
+            <a:lstStyle/>
+            <a:p>
+              <a:r>
+                <a:rPr lang="en-IE" dirty="0"/>
+                <a:t>House house1 = new House();</a:t>
+              </a:r>
+            </a:p>
+            <a:p>
+              <a:r>
+                <a:rPr lang="en-IE" dirty="0"/>
+                <a:t>house1.windowType = “Bay”</a:t>
+              </a:r>
+            </a:p>
+            <a:p>
+              <a:r>
+                <a:rPr lang="en-IE" dirty="0"/>
+                <a:t>house1.numRooms = 20</a:t>
+              </a:r>
+            </a:p>
+            <a:p>
+              <a:r>
+                <a:rPr lang="en-IE" dirty="0"/>
+                <a:t>house1.colour = “Blue”</a:t>
+              </a:r>
+            </a:p>
+            <a:p>
+              <a:endParaRPr lang="en-IE" dirty="0"/>
+            </a:p>
+            <a:p>
+              <a:r>
+                <a:rPr lang="en-IE" dirty="0"/>
+                <a:t>house1.</a:t>
+              </a:r>
+              <a:r>
+                <a:rPr lang="en-IE" dirty="0">
+                  <a:solidFill>
+                    <a:schemeClr val="accent2"/>
+                  </a:solidFill>
+                </a:rPr>
+                <a:t>display</a:t>
+              </a:r>
+              <a:r>
+                <a:rPr lang="en-IE" dirty="0"/>
+                <a:t>()</a:t>
+              </a:r>
+            </a:p>
+          </p:txBody>
+        </p:sp>
+      </p:grpSp>
+      <p:grpSp>
+        <p:nvGrpSpPr>
+          <p:cNvPr id="15" name="Group 14">
+            <a:extLst>
+              <a:ext uri="{FF2B5EF4-FFF2-40B4-BE49-F238E27FC236}">
+                <a16:creationId xmlns:a16="http://schemas.microsoft.com/office/drawing/2014/main" id="{3EF67239-0014-CA92-0673-2E6E2D7DDC99}"/>
+              </a:ext>
+            </a:extLst>
+          </p:cNvPr>
+          <p:cNvGrpSpPr/>
+          <p:nvPr/>
+        </p:nvGrpSpPr>
+        <p:grpSpPr>
+          <a:xfrm>
+            <a:off x="6336385" y="2932982"/>
+            <a:ext cx="5226457" cy="3490918"/>
+            <a:chOff x="-257009" y="2932173"/>
+            <a:chExt cx="5226457" cy="3490918"/>
+          </a:xfrm>
+        </p:grpSpPr>
+        <p:grpSp>
+          <p:nvGrpSpPr>
+            <p:cNvPr id="16" name="Group 15">
+              <a:extLst>
+                <a:ext uri="{FF2B5EF4-FFF2-40B4-BE49-F238E27FC236}">
+                  <a16:creationId xmlns:a16="http://schemas.microsoft.com/office/drawing/2014/main" id="{A8227866-DA29-08DF-AE34-4FA0C7C7862F}"/>
+                </a:ext>
+              </a:extLst>
+            </p:cNvPr>
+            <p:cNvGrpSpPr/>
+            <p:nvPr/>
+          </p:nvGrpSpPr>
+          <p:grpSpPr>
+            <a:xfrm>
+              <a:off x="-257009" y="2932173"/>
+              <a:ext cx="5226457" cy="1736592"/>
+              <a:chOff x="-257009" y="3633795"/>
+              <a:chExt cx="5226457" cy="1736592"/>
+            </a:xfrm>
+          </p:grpSpPr>
+          <p:grpSp>
+            <p:nvGrpSpPr>
+              <p:cNvPr id="18" name="Group 17">
+                <a:extLst>
+                  <a:ext uri="{FF2B5EF4-FFF2-40B4-BE49-F238E27FC236}">
+                    <a16:creationId xmlns:a16="http://schemas.microsoft.com/office/drawing/2014/main" id="{3952E808-E69B-5683-E073-61788B36EFF7}"/>
+                  </a:ext>
+                </a:extLst>
+              </p:cNvPr>
+              <p:cNvGrpSpPr/>
+              <p:nvPr/>
+            </p:nvGrpSpPr>
+            <p:grpSpPr>
+              <a:xfrm>
+                <a:off x="-257009" y="3633795"/>
+                <a:ext cx="5226457" cy="1736592"/>
+                <a:chOff x="-257009" y="3633795"/>
+                <a:chExt cx="5226457" cy="1736592"/>
+              </a:xfrm>
+            </p:grpSpPr>
+            <p:sp>
+              <p:nvSpPr>
+                <p:cNvPr id="20" name="Rectangle: Rounded Corners 19">
+                  <a:extLst>
+                    <a:ext uri="{FF2B5EF4-FFF2-40B4-BE49-F238E27FC236}">
+                      <a16:creationId xmlns:a16="http://schemas.microsoft.com/office/drawing/2014/main" id="{D60CEF87-AB7F-A5C4-DAC9-53EDCD462D9F}"/>
+                    </a:ext>
+                  </a:extLst>
+                </p:cNvPr>
+                <p:cNvSpPr/>
+                <p:nvPr/>
+              </p:nvSpPr>
+              <p:spPr>
+                <a:xfrm>
+                  <a:off x="966153" y="3633795"/>
+                  <a:ext cx="4003295" cy="1736592"/>
+                </a:xfrm>
+                <a:prstGeom prst="roundRect">
+                  <a:avLst/>
+                </a:prstGeom>
+                <a:noFill/>
+              </p:spPr>
+              <p:style>
+                <a:lnRef idx="2">
+                  <a:schemeClr val="accent1">
+                    <a:shade val="15000"/>
+                  </a:schemeClr>
+                </a:lnRef>
+                <a:fillRef idx="1">
+                  <a:schemeClr val="accent1"/>
+                </a:fillRef>
+                <a:effectRef idx="0">
+                  <a:schemeClr val="accent1"/>
+                </a:effectRef>
+                <a:fontRef idx="minor">
+                  <a:schemeClr val="lt1"/>
+                </a:fontRef>
+              </p:style>
+              <p:txBody>
+                <a:bodyPr rtlCol="0" anchor="ctr"/>
+                <a:lstStyle/>
+                <a:p>
+                  <a:r>
+                    <a:rPr lang="en-IE" dirty="0" err="1">
+                      <a:solidFill>
+                        <a:schemeClr val="tx1">
+                          <a:lumMod val="75000"/>
+                          <a:lumOff val="25000"/>
+                        </a:schemeClr>
+                      </a:solidFill>
+                    </a:rPr>
+                    <a:t>windowType</a:t>
+                  </a:r>
+                  <a:r>
+                    <a:rPr lang="en-IE" dirty="0">
+                      <a:solidFill>
+                        <a:schemeClr val="tx1">
+                          <a:lumMod val="75000"/>
+                          <a:lumOff val="25000"/>
+                        </a:schemeClr>
+                      </a:solidFill>
+                    </a:rPr>
+                    <a:t> = “Picture”</a:t>
+                  </a:r>
+                </a:p>
+                <a:p>
+                  <a:r>
+                    <a:rPr lang="en-IE" dirty="0" err="1">
+                      <a:solidFill>
+                        <a:schemeClr val="tx1">
+                          <a:lumMod val="75000"/>
+                          <a:lumOff val="25000"/>
+                        </a:schemeClr>
+                      </a:solidFill>
+                    </a:rPr>
+                    <a:t>numRooms</a:t>
+                  </a:r>
+                  <a:r>
+                    <a:rPr lang="en-IE" dirty="0">
+                      <a:solidFill>
+                        <a:schemeClr val="tx1">
+                          <a:lumMod val="75000"/>
+                          <a:lumOff val="25000"/>
+                        </a:schemeClr>
+                      </a:solidFill>
+                    </a:rPr>
+                    <a:t>  = 10 </a:t>
+                  </a:r>
+                </a:p>
+                <a:p>
+                  <a:r>
+                    <a:rPr lang="en-IE" dirty="0">
+                      <a:solidFill>
+                        <a:schemeClr val="tx1">
+                          <a:lumMod val="75000"/>
+                          <a:lumOff val="25000"/>
+                        </a:schemeClr>
+                      </a:solidFill>
+                    </a:rPr>
+                    <a:t>colour  = “Orange”</a:t>
+                  </a:r>
+                </a:p>
+                <a:p>
+                  <a:endParaRPr lang="en-IE" dirty="0">
+                    <a:solidFill>
+                      <a:schemeClr val="tx1">
+                        <a:lumMod val="75000"/>
+                        <a:lumOff val="25000"/>
+                      </a:schemeClr>
+                    </a:solidFill>
+                  </a:endParaRPr>
+                </a:p>
+                <a:p>
+                  <a:r>
+                    <a:rPr lang="en-IE" dirty="0">
+                      <a:solidFill>
+                        <a:srgbClr val="C00000"/>
+                      </a:solidFill>
+                      <a:latin typeface="Consolas" panose="020B0609020204030204" pitchFamily="49" charset="0"/>
+                    </a:rPr>
+                    <a:t>public void display()</a:t>
+                  </a:r>
+                </a:p>
+              </p:txBody>
+            </p:sp>
+            <p:sp>
+              <p:nvSpPr>
+                <p:cNvPr id="21" name="TextBox 20">
+                  <a:extLst>
+                    <a:ext uri="{FF2B5EF4-FFF2-40B4-BE49-F238E27FC236}">
+                      <a16:creationId xmlns:a16="http://schemas.microsoft.com/office/drawing/2014/main" id="{0626322C-B63A-C79C-8593-173AA374A3BF}"/>
+                    </a:ext>
+                  </a:extLst>
+                </p:cNvPr>
+                <p:cNvSpPr txBox="1"/>
+                <p:nvPr/>
+              </p:nvSpPr>
+              <p:spPr>
+                <a:xfrm>
+                  <a:off x="-257009" y="4364966"/>
+                  <a:ext cx="872355" cy="369332"/>
+                </a:xfrm>
+                <a:prstGeom prst="rect">
+                  <a:avLst/>
+                </a:prstGeom>
+                <a:noFill/>
+              </p:spPr>
+              <p:txBody>
+                <a:bodyPr wrap="none" rtlCol="0">
+                  <a:spAutoFit/>
+                </a:bodyPr>
+                <a:lstStyle/>
+                <a:p>
+                  <a:r>
+                    <a:rPr lang="en-IE" dirty="0"/>
+                    <a:t>house2</a:t>
+                  </a:r>
+                </a:p>
+              </p:txBody>
+            </p:sp>
+          </p:grpSp>
+          <p:cxnSp>
+            <p:nvCxnSpPr>
+              <p:cNvPr id="19" name="Straight Arrow Connector 18">
+                <a:extLst>
+                  <a:ext uri="{FF2B5EF4-FFF2-40B4-BE49-F238E27FC236}">
+                    <a16:creationId xmlns:a16="http://schemas.microsoft.com/office/drawing/2014/main" id="{ECB4A4FA-B920-815B-E26C-C1CCB0FD4C3A}"/>
+                  </a:ext>
+                </a:extLst>
+              </p:cNvPr>
+              <p:cNvCxnSpPr>
+                <a:stCxn id="21" idx="3"/>
+              </p:cNvCxnSpPr>
+              <p:nvPr/>
+            </p:nvCxnSpPr>
+            <p:spPr>
+              <a:xfrm flipV="1">
+                <a:off x="615346" y="4520242"/>
+                <a:ext cx="350807" cy="29390"/>
+              </a:xfrm>
+              <a:prstGeom prst="straightConnector1">
+                <a:avLst/>
+              </a:prstGeom>
+              <a:ln>
+                <a:tailEnd type="triangle"/>
+              </a:ln>
+            </p:spPr>
+            <p:style>
+              <a:lnRef idx="1">
+                <a:schemeClr val="accent1"/>
+              </a:lnRef>
+              <a:fillRef idx="0">
+                <a:schemeClr val="accent1"/>
+              </a:fillRef>
+              <a:effectRef idx="0">
+                <a:schemeClr val="accent1"/>
+              </a:effectRef>
+              <a:fontRef idx="minor">
+                <a:schemeClr val="tx1"/>
+              </a:fontRef>
+            </p:style>
+          </p:cxnSp>
+        </p:grpSp>
+        <p:sp>
+          <p:nvSpPr>
+            <p:cNvPr id="17" name="TextBox 16">
+              <a:extLst>
+                <a:ext uri="{FF2B5EF4-FFF2-40B4-BE49-F238E27FC236}">
+                  <a16:creationId xmlns:a16="http://schemas.microsoft.com/office/drawing/2014/main" id="{054BA842-B7AB-C7B2-124C-CDCD0169104E}"/>
+                </a:ext>
+              </a:extLst>
+            </p:cNvPr>
+            <p:cNvSpPr txBox="1"/>
+            <p:nvPr/>
+          </p:nvSpPr>
+          <p:spPr>
+            <a:xfrm>
+              <a:off x="1329362" y="4668765"/>
+              <a:ext cx="3456573" cy="1754326"/>
+            </a:xfrm>
+            <a:prstGeom prst="rect">
+              <a:avLst/>
+            </a:prstGeom>
+            <a:noFill/>
+          </p:spPr>
+          <p:txBody>
+            <a:bodyPr wrap="square" rtlCol="0">
+              <a:spAutoFit/>
+            </a:bodyPr>
+            <a:lstStyle/>
+            <a:p>
+              <a:r>
+                <a:rPr lang="en-IE" dirty="0"/>
+                <a:t>House house2 = new House();</a:t>
+              </a:r>
+            </a:p>
+            <a:p>
+              <a:r>
+                <a:rPr lang="en-IE" dirty="0"/>
+                <a:t>house2.windowType = “Picture”</a:t>
+              </a:r>
+            </a:p>
+            <a:p>
+              <a:r>
+                <a:rPr lang="en-IE" dirty="0"/>
+                <a:t>house2.numRooms = 10</a:t>
+              </a:r>
+            </a:p>
+            <a:p>
+              <a:r>
+                <a:rPr lang="en-IE" dirty="0"/>
+                <a:t>house2.colour = “Orange”</a:t>
+              </a:r>
+            </a:p>
+            <a:p>
+              <a:endParaRPr lang="en-IE" dirty="0"/>
+            </a:p>
+            <a:p>
+              <a:r>
+                <a:rPr lang="en-IE" dirty="0"/>
+                <a:t>house2.</a:t>
+              </a:r>
+              <a:r>
+                <a:rPr lang="en-IE" dirty="0">
+                  <a:solidFill>
+                    <a:srgbClr val="C00000"/>
+                  </a:solidFill>
+                </a:rPr>
+                <a:t>display()</a:t>
+              </a:r>
+            </a:p>
+          </p:txBody>
+        </p:sp>
+      </p:grpSp>
+      <p:cxnSp>
+        <p:nvCxnSpPr>
+          <p:cNvPr id="11" name="Connector: Elbow 10">
+            <a:extLst>
+              <a:ext uri="{FF2B5EF4-FFF2-40B4-BE49-F238E27FC236}">
+                <a16:creationId xmlns:a16="http://schemas.microsoft.com/office/drawing/2014/main" id="{C97DB13F-4CC9-D5EA-B95E-69E159ED3C45}"/>
+              </a:ext>
+            </a:extLst>
+          </p:cNvPr>
+          <p:cNvCxnSpPr>
+            <a:cxnSpLocks/>
+          </p:cNvCxnSpPr>
+          <p:nvPr/>
+        </p:nvCxnSpPr>
+        <p:spPr>
+          <a:xfrm rot="16200000" flipV="1">
+            <a:off x="4010302" y="5122196"/>
+            <a:ext cx="1880557" cy="343093"/>
+          </a:xfrm>
+          <a:prstGeom prst="bentConnector3">
+            <a:avLst>
+              <a:gd name="adj1" fmla="val 99847"/>
+            </a:avLst>
+          </a:prstGeom>
+          <a:ln>
+            <a:tailEnd type="triangle"/>
+          </a:ln>
+        </p:spPr>
+        <p:style>
+          <a:lnRef idx="1">
+            <a:schemeClr val="accent1"/>
+          </a:lnRef>
+          <a:fillRef idx="0">
+            <a:schemeClr val="accent1"/>
+          </a:fillRef>
+          <a:effectRef idx="0">
+            <a:schemeClr val="accent1"/>
+          </a:effectRef>
+          <a:fontRef idx="minor">
+            <a:schemeClr val="tx1"/>
+          </a:fontRef>
+        </p:style>
+      </p:cxnSp>
+      <p:grpSp>
+        <p:nvGrpSpPr>
+          <p:cNvPr id="32" name="Group 31">
+            <a:extLst>
+              <a:ext uri="{FF2B5EF4-FFF2-40B4-BE49-F238E27FC236}">
+                <a16:creationId xmlns:a16="http://schemas.microsoft.com/office/drawing/2014/main" id="{15DF6CBB-01BA-6187-C035-CC89BDA87652}"/>
+              </a:ext>
+            </a:extLst>
+          </p:cNvPr>
+          <p:cNvGrpSpPr/>
+          <p:nvPr/>
+        </p:nvGrpSpPr>
+        <p:grpSpPr>
+          <a:xfrm>
+            <a:off x="7208740" y="4376468"/>
+            <a:ext cx="714016" cy="1880558"/>
+            <a:chOff x="7056408" y="4376468"/>
+            <a:chExt cx="866348" cy="1880558"/>
+          </a:xfrm>
+        </p:grpSpPr>
+        <p:cxnSp>
+          <p:nvCxnSpPr>
+            <p:cNvPr id="28" name="Connector: Elbow 27">
+              <a:extLst>
+                <a:ext uri="{FF2B5EF4-FFF2-40B4-BE49-F238E27FC236}">
+                  <a16:creationId xmlns:a16="http://schemas.microsoft.com/office/drawing/2014/main" id="{B5A92CA9-96FA-2F8C-D63C-259DF59A1DF7}"/>
+                </a:ext>
+              </a:extLst>
+            </p:cNvPr>
+            <p:cNvCxnSpPr/>
+            <p:nvPr/>
+          </p:nvCxnSpPr>
+          <p:spPr>
+            <a:xfrm rot="5400000" flipH="1" flipV="1">
+              <a:off x="6426679" y="5011947"/>
+              <a:ext cx="1880558" cy="609600"/>
+            </a:xfrm>
+            <a:prstGeom prst="bentConnector3">
+              <a:avLst>
+                <a:gd name="adj1" fmla="val 99541"/>
+              </a:avLst>
+            </a:prstGeom>
+            <a:ln>
+              <a:solidFill>
+                <a:srgbClr val="C00000"/>
+              </a:solidFill>
+              <a:tailEnd type="triangle"/>
+            </a:ln>
+          </p:spPr>
+          <p:style>
+            <a:lnRef idx="1">
+              <a:schemeClr val="accent1"/>
+            </a:lnRef>
+            <a:fillRef idx="0">
+              <a:schemeClr val="accent1"/>
+            </a:fillRef>
+            <a:effectRef idx="0">
+              <a:schemeClr val="accent1"/>
+            </a:effectRef>
+            <a:fontRef idx="minor">
+              <a:schemeClr val="tx1"/>
+            </a:fontRef>
+          </p:style>
+        </p:cxnSp>
+        <p:cxnSp>
+          <p:nvCxnSpPr>
+            <p:cNvPr id="31" name="Straight Connector 30">
+              <a:extLst>
+                <a:ext uri="{FF2B5EF4-FFF2-40B4-BE49-F238E27FC236}">
+                  <a16:creationId xmlns:a16="http://schemas.microsoft.com/office/drawing/2014/main" id="{64C7713C-FC84-A948-6D37-D63B5E37FB70}"/>
+                </a:ext>
+              </a:extLst>
+            </p:cNvPr>
+            <p:cNvCxnSpPr/>
+            <p:nvPr/>
+          </p:nvCxnSpPr>
+          <p:spPr>
+            <a:xfrm flipH="1">
+              <a:off x="7056408" y="6257026"/>
+              <a:ext cx="866348" cy="0"/>
+            </a:xfrm>
+            <a:prstGeom prst="line">
+              <a:avLst/>
+            </a:prstGeom>
+            <a:ln>
+              <a:solidFill>
+                <a:srgbClr val="C00000"/>
+              </a:solidFill>
+            </a:ln>
+          </p:spPr>
+          <p:style>
+            <a:lnRef idx="1">
+              <a:schemeClr val="accent1"/>
+            </a:lnRef>
+            <a:fillRef idx="0">
+              <a:schemeClr val="accent1"/>
+            </a:fillRef>
+            <a:effectRef idx="0">
+              <a:schemeClr val="accent1"/>
+            </a:effectRef>
+            <a:fontRef idx="minor">
+              <a:schemeClr val="tx1"/>
+            </a:fontRef>
+          </p:style>
+        </p:cxnSp>
+      </p:grpSp>
+      <p:cxnSp>
+        <p:nvCxnSpPr>
+          <p:cNvPr id="39" name="Straight Connector 38">
+            <a:extLst>
+              <a:ext uri="{FF2B5EF4-FFF2-40B4-BE49-F238E27FC236}">
+                <a16:creationId xmlns:a16="http://schemas.microsoft.com/office/drawing/2014/main" id="{87DDB547-43CF-828F-68EB-C52EA7CCAC64}"/>
+              </a:ext>
+            </a:extLst>
+          </p:cNvPr>
+          <p:cNvCxnSpPr/>
+          <p:nvPr/>
+        </p:nvCxnSpPr>
+        <p:spPr>
+          <a:xfrm>
+            <a:off x="3024996" y="6257026"/>
+            <a:ext cx="2093344" cy="0"/>
+          </a:xfrm>
+          <a:prstGeom prst="line">
+            <a:avLst/>
+          </a:prstGeom>
+        </p:spPr>
+        <p:style>
+          <a:lnRef idx="1">
+            <a:schemeClr val="accent1"/>
+          </a:lnRef>
+          <a:fillRef idx="0">
+            <a:schemeClr val="accent1"/>
+          </a:fillRef>
+          <a:effectRef idx="0">
+            <a:schemeClr val="accent1"/>
+          </a:effectRef>
+          <a:fontRef idx="minor">
+            <a:schemeClr val="tx1"/>
+          </a:fontRef>
+        </p:style>
+      </p:cxnSp>
+    </p:spTree>
+    <p:extLst>
+      <p:ext uri="{BB962C8B-B14F-4D97-AF65-F5344CB8AC3E}">
+        <p14:creationId xmlns:p14="http://schemas.microsoft.com/office/powerpoint/2010/main" val="3024442204"/>
+      </p:ext>
+    </p:extLst>
+  </p:cSld>
+  <p:clrMapOvr>
+    <a:masterClrMapping/>
+  </p:clrMapOvr>
+</p:sld>
+</file>
+
+<file path=ppt/slides/slide2.xml><?xml version="1.0" encoding="utf-8"?>
+<p:sld xmlns:a="http://schemas.openxmlformats.org/drawingml/2006/main" xmlns:r="http://schemas.openxmlformats.org/officeDocument/2006/relationships" xmlns:p="http://schemas.openxmlformats.org/presentationml/2006/main">
+  <p:cSld>
+    <p:spTree>
+      <p:nvGrpSpPr>
+        <p:cNvPr id="1" name=""/>
+        <p:cNvGrpSpPr/>
+        <p:nvPr/>
+      </p:nvGrpSpPr>
+      <p:grpSpPr>
+        <a:xfrm>
+          <a:off x="0" y="0"/>
+          <a:ext cx="0" cy="0"/>
+          <a:chOff x="0" y="0"/>
+          <a:chExt cx="0" cy="0"/>
+        </a:xfrm>
+      </p:grpSpPr>
+      <p:sp>
+        <p:nvSpPr>
+          <p:cNvPr id="2" name="Title 1">
+            <a:extLst>
+              <a:ext uri="{FF2B5EF4-FFF2-40B4-BE49-F238E27FC236}">
+                <a16:creationId xmlns:a16="http://schemas.microsoft.com/office/drawing/2014/main" id="{4D1322FC-6F1A-7F00-8E44-3DD659EF9DFB}"/>
+              </a:ext>
+            </a:extLst>
+          </p:cNvPr>
+          <p:cNvSpPr>
+            <a:spLocks noGrp="1"/>
+          </p:cNvSpPr>
+          <p:nvPr>
+            <p:ph type="title"/>
+          </p:nvPr>
+        </p:nvSpPr>
+        <p:spPr/>
+        <p:txBody>
+          <a:bodyPr/>
+          <a:lstStyle/>
+          <a:p>
+            <a:r>
+              <a:rPr lang="en-IE" dirty="0"/>
+              <a:t>A Note on Programming Styles</a:t>
+            </a:r>
+          </a:p>
+        </p:txBody>
+      </p:sp>
+      <p:sp>
+        <p:nvSpPr>
+          <p:cNvPr id="3" name="Content Placeholder 2">
+            <a:extLst>
+              <a:ext uri="{FF2B5EF4-FFF2-40B4-BE49-F238E27FC236}">
+                <a16:creationId xmlns:a16="http://schemas.microsoft.com/office/drawing/2014/main" id="{BD42BF5C-A4DA-8B00-EC4A-6FAC5BEB4D1D}"/>
+              </a:ext>
+            </a:extLst>
+          </p:cNvPr>
+          <p:cNvSpPr>
+            <a:spLocks noGrp="1"/>
+          </p:cNvSpPr>
+          <p:nvPr>
+            <p:ph idx="1"/>
+          </p:nvPr>
+        </p:nvSpPr>
+        <p:spPr/>
+        <p:txBody>
+          <a:bodyPr>
+            <a:normAutofit fontScale="92500" lnSpcReduction="10000"/>
+          </a:bodyPr>
+          <a:lstStyle/>
+          <a:p>
+            <a:pPr lvl="1"/>
+            <a:r>
+              <a:rPr lang="en-IE" sz="3200" dirty="0"/>
+              <a:t>Up until now we have used </a:t>
+            </a:r>
+            <a:r>
+              <a:rPr lang="en-IE" sz="3200" u="sng" dirty="0"/>
+              <a:t>procedural</a:t>
+            </a:r>
+            <a:r>
+              <a:rPr lang="en-IE" sz="3200" dirty="0"/>
+              <a:t> programming</a:t>
+            </a:r>
+          </a:p>
+          <a:p>
+            <a:pPr lvl="2"/>
+            <a:r>
+              <a:rPr lang="en-IE" sz="2800" dirty="0">
+                <a:solidFill>
+                  <a:srgbClr val="FF0000"/>
+                </a:solidFill>
+              </a:rPr>
+              <a:t>Action</a:t>
+            </a:r>
+            <a:r>
+              <a:rPr lang="en-IE" sz="2800" dirty="0"/>
+              <a:t>-driven</a:t>
+            </a:r>
+          </a:p>
+          <a:p>
+            <a:pPr lvl="2"/>
+            <a:r>
+              <a:rPr lang="en-IE" sz="2800" dirty="0"/>
+              <a:t>Call procedures (functions) to carry out actions</a:t>
+            </a:r>
+          </a:p>
+          <a:p>
+            <a:pPr lvl="2"/>
+            <a:r>
+              <a:rPr lang="en-IE" sz="2800" dirty="0"/>
+              <a:t>Everything is about steps/logic to be done, not about data to be worked with</a:t>
+            </a:r>
+          </a:p>
+          <a:p>
+            <a:pPr lvl="2"/>
+            <a:endParaRPr lang="en-IE" sz="2800" dirty="0"/>
+          </a:p>
+          <a:p>
+            <a:pPr lvl="1"/>
+            <a:r>
+              <a:rPr lang="en-IE" sz="3200" dirty="0"/>
+              <a:t>Another programming style is </a:t>
+            </a:r>
+            <a:r>
+              <a:rPr lang="en-IE" sz="3200" u="sng" dirty="0"/>
+              <a:t>object-oriented</a:t>
+            </a:r>
+            <a:r>
+              <a:rPr lang="en-IE" sz="3200" dirty="0"/>
+              <a:t> programming</a:t>
+            </a:r>
+          </a:p>
+          <a:p>
+            <a:pPr lvl="2"/>
+            <a:r>
+              <a:rPr lang="en-IE" sz="2800" dirty="0">
+                <a:solidFill>
+                  <a:srgbClr val="FF0000"/>
+                </a:solidFill>
+              </a:rPr>
+              <a:t>Data</a:t>
+            </a:r>
+            <a:r>
+              <a:rPr lang="en-IE" sz="2800" dirty="0"/>
+              <a:t>-driven</a:t>
+            </a:r>
+          </a:p>
+          <a:p>
+            <a:pPr lvl="2"/>
+            <a:r>
+              <a:rPr lang="en-IE" sz="2800" dirty="0"/>
+              <a:t>Data is bundled in objects</a:t>
+            </a:r>
+          </a:p>
+          <a:p>
+            <a:pPr lvl="2"/>
+            <a:r>
+              <a:rPr lang="en-IE" sz="2800" dirty="0"/>
+              <a:t>Objects have abilities (methods) they can perform on their own data</a:t>
+            </a:r>
+          </a:p>
+          <a:p>
+            <a:pPr lvl="2"/>
+            <a:endParaRPr lang="en-IE" sz="2800" dirty="0"/>
+          </a:p>
+        </p:txBody>
+      </p:sp>
+    </p:spTree>
+    <p:extLst>
+      <p:ext uri="{BB962C8B-B14F-4D97-AF65-F5344CB8AC3E}">
+        <p14:creationId xmlns:p14="http://schemas.microsoft.com/office/powerpoint/2010/main" val="440946638"/>
+      </p:ext>
+    </p:extLst>
+  </p:cSld>
+  <p:clrMapOvr>
+    <a:masterClrMapping/>
+  </p:clrMapOvr>
+</p:sld>
+</file>
+
+<file path=ppt/slides/slide20.xml><?xml version="1.0" encoding="utf-8"?>
+<p:sld xmlns:a="http://schemas.openxmlformats.org/drawingml/2006/main" xmlns:r="http://schemas.openxmlformats.org/officeDocument/2006/relationships" xmlns:p="http://schemas.openxmlformats.org/presentationml/2006/main">
+  <p:cSld>
+    <p:spTree>
+      <p:nvGrpSpPr>
+        <p:cNvPr id="1" name=""/>
+        <p:cNvGrpSpPr/>
+        <p:nvPr/>
+      </p:nvGrpSpPr>
+      <p:grpSpPr>
+        <a:xfrm>
+          <a:off x="0" y="0"/>
+          <a:ext cx="0" cy="0"/>
+          <a:chOff x="0" y="0"/>
+          <a:chExt cx="0" cy="0"/>
+        </a:xfrm>
+      </p:grpSpPr>
+      <p:sp>
+        <p:nvSpPr>
+          <p:cNvPr id="2" name="Title 1">
+            <a:extLst>
+              <a:ext uri="{FF2B5EF4-FFF2-40B4-BE49-F238E27FC236}">
                 <a16:creationId xmlns:a16="http://schemas.microsoft.com/office/drawing/2014/main" id="{976CFD5D-FEF0-502C-2E2D-E157CB404865}"/>
               </a:ext>
             </a:extLst>
@@ -6746,8 +9263,8 @@
         </p:nvSpPr>
         <p:spPr>
           <a:xfrm>
-            <a:off x="178279" y="6242732"/>
-            <a:ext cx="5124092" cy="328665"/>
+            <a:off x="178278" y="6242732"/>
+            <a:ext cx="5221857" cy="328665"/>
           </a:xfrm>
           <a:prstGeom prst="roundRect">
             <a:avLst/>
@@ -6775,7 +9292,15 @@
           <a:p>
             <a:r>
               <a:rPr lang="en-IE" sz="1700" dirty="0" err="1"/>
-              <a:t>slide_examples.introducing_classes</a:t>
+              <a:t>slide_examples</a:t>
+            </a:r>
+            <a:r>
+              <a:rPr lang="en-IE" sz="1700" dirty="0"/>
+              <a:t>/</a:t>
+            </a:r>
+            <a:r>
+              <a:rPr lang="en-IE" sz="1700" dirty="0" err="1"/>
+              <a:t>introducing_classes</a:t>
             </a:r>
             <a:r>
               <a:rPr lang="en-IE" sz="1700" dirty="0"/>
@@ -6872,7 +9397,7 @@
 </p:sld>
 </file>
 
-<file path=ppt/slides/slide19.xml><?xml version="1.0" encoding="utf-8"?>
+<file path=ppt/slides/slide21.xml><?xml version="1.0" encoding="utf-8"?>
 <p:sld xmlns:a="http://schemas.openxmlformats.org/drawingml/2006/main" xmlns:r="http://schemas.openxmlformats.org/officeDocument/2006/relationships" xmlns:p="http://schemas.openxmlformats.org/presentationml/2006/main">
   <p:cSld>
     <p:spTree>
@@ -7228,7 +9753,15 @@
           <a:p>
             <a:r>
               <a:rPr lang="en-IE" sz="1700" dirty="0" err="1"/>
-              <a:t>slide_examples.introducing_classes</a:t>
+              <a:t>slide_examples</a:t>
+            </a:r>
+            <a:r>
+              <a:rPr lang="en-IE" sz="1700" dirty="0"/>
+              <a:t>/</a:t>
+            </a:r>
+            <a:r>
+              <a:rPr lang="en-IE" sz="1700" dirty="0" err="1"/>
+              <a:t>introducing_classes</a:t>
             </a:r>
             <a:r>
               <a:rPr lang="en-IE" sz="1700" dirty="0"/>
@@ -7293,185 +9826,7 @@
 </p:sld>
 </file>
 
-<file path=ppt/slides/slide2.xml><?xml version="1.0" encoding="utf-8"?>
-<p:sld xmlns:a="http://schemas.openxmlformats.org/drawingml/2006/main" xmlns:r="http://schemas.openxmlformats.org/officeDocument/2006/relationships" xmlns:p="http://schemas.openxmlformats.org/presentationml/2006/main">
-  <p:cSld>
-    <p:spTree>
-      <p:nvGrpSpPr>
-        <p:cNvPr id="1" name=""/>
-        <p:cNvGrpSpPr/>
-        <p:nvPr/>
-      </p:nvGrpSpPr>
-      <p:grpSpPr>
-        <a:xfrm>
-          <a:off x="0" y="0"/>
-          <a:ext cx="0" cy="0"/>
-          <a:chOff x="0" y="0"/>
-          <a:chExt cx="0" cy="0"/>
-        </a:xfrm>
-      </p:grpSpPr>
-      <p:sp>
-        <p:nvSpPr>
-          <p:cNvPr id="2" name="Title 1">
-            <a:extLst>
-              <a:ext uri="{FF2B5EF4-FFF2-40B4-BE49-F238E27FC236}">
-                <a16:creationId xmlns:a16="http://schemas.microsoft.com/office/drawing/2014/main" id="{4D1322FC-6F1A-7F00-8E44-3DD659EF9DFB}"/>
-              </a:ext>
-            </a:extLst>
-          </p:cNvPr>
-          <p:cNvSpPr>
-            <a:spLocks noGrp="1"/>
-          </p:cNvSpPr>
-          <p:nvPr>
-            <p:ph type="title"/>
-          </p:nvPr>
-        </p:nvSpPr>
-        <p:spPr/>
-        <p:txBody>
-          <a:bodyPr/>
-          <a:lstStyle/>
-          <a:p>
-            <a:r>
-              <a:rPr lang="en-IE" dirty="0"/>
-              <a:t>A Note on Programming Styles</a:t>
-            </a:r>
-          </a:p>
-        </p:txBody>
-      </p:sp>
-      <p:sp>
-        <p:nvSpPr>
-          <p:cNvPr id="3" name="Content Placeholder 2">
-            <a:extLst>
-              <a:ext uri="{FF2B5EF4-FFF2-40B4-BE49-F238E27FC236}">
-                <a16:creationId xmlns:a16="http://schemas.microsoft.com/office/drawing/2014/main" id="{BD42BF5C-A4DA-8B00-EC4A-6FAC5BEB4D1D}"/>
-              </a:ext>
-            </a:extLst>
-          </p:cNvPr>
-          <p:cNvSpPr>
-            <a:spLocks noGrp="1"/>
-          </p:cNvSpPr>
-          <p:nvPr>
-            <p:ph idx="1"/>
-          </p:nvPr>
-        </p:nvSpPr>
-        <p:spPr/>
-        <p:txBody>
-          <a:bodyPr>
-            <a:normAutofit fontScale="92500" lnSpcReduction="10000"/>
-          </a:bodyPr>
-          <a:lstStyle/>
-          <a:p>
-            <a:pPr lvl="1"/>
-            <a:r>
-              <a:rPr lang="en-IE" sz="3200" dirty="0"/>
-              <a:t>Up until now we have used </a:t>
-            </a:r>
-            <a:r>
-              <a:rPr lang="en-IE" sz="3200" u="sng" dirty="0"/>
-              <a:t>procedural</a:t>
-            </a:r>
-            <a:r>
-              <a:rPr lang="en-IE" sz="3200" dirty="0"/>
-              <a:t> programming</a:t>
-            </a:r>
-          </a:p>
-          <a:p>
-            <a:pPr lvl="2"/>
-            <a:r>
-              <a:rPr lang="en-IE" sz="2800" dirty="0">
-                <a:solidFill>
-                  <a:srgbClr val="FF0000"/>
-                </a:solidFill>
-              </a:rPr>
-              <a:t>Action</a:t>
-            </a:r>
-            <a:r>
-              <a:rPr lang="en-IE" sz="2800" dirty="0"/>
-              <a:t>-driven</a:t>
-            </a:r>
-          </a:p>
-          <a:p>
-            <a:pPr lvl="2"/>
-            <a:r>
-              <a:rPr lang="en-IE" sz="2800" dirty="0"/>
-              <a:t>Call procedures (functions) to carry out actions</a:t>
-            </a:r>
-          </a:p>
-          <a:p>
-            <a:pPr lvl="2"/>
-            <a:r>
-              <a:rPr lang="en-IE" sz="2800" dirty="0"/>
-              <a:t>Everything is about steps/logic to be done, not about data to be worked with</a:t>
-            </a:r>
-          </a:p>
-          <a:p>
-            <a:pPr lvl="2"/>
-            <a:endParaRPr lang="en-IE" sz="2800" dirty="0"/>
-          </a:p>
-          <a:p>
-            <a:pPr lvl="1"/>
-            <a:r>
-              <a:rPr lang="en-IE" sz="3200" dirty="0"/>
-              <a:t>Another programming style is </a:t>
-            </a:r>
-            <a:r>
-              <a:rPr lang="en-IE" sz="3200" u="sng" dirty="0"/>
-              <a:t>object-oriented</a:t>
-            </a:r>
-            <a:r>
-              <a:rPr lang="en-IE" sz="3200" dirty="0"/>
-              <a:t> programming</a:t>
-            </a:r>
-          </a:p>
-          <a:p>
-            <a:pPr lvl="2"/>
-            <a:r>
-              <a:rPr lang="en-IE" sz="2800" dirty="0">
-                <a:solidFill>
-                  <a:srgbClr val="FF0000"/>
-                </a:solidFill>
-              </a:rPr>
-              <a:t>Data</a:t>
-            </a:r>
-            <a:r>
-              <a:rPr lang="en-IE" sz="2800" dirty="0"/>
-              <a:t>-driven</a:t>
-            </a:r>
-          </a:p>
-          <a:p>
-            <a:pPr lvl="2"/>
-            <a:r>
-              <a:rPr lang="en-IE" sz="2800" dirty="0"/>
-              <a:t>Data is bundled in objects</a:t>
-            </a:r>
-          </a:p>
-          <a:p>
-            <a:pPr lvl="2"/>
-            <a:r>
-              <a:rPr lang="en-IE" sz="2800" dirty="0"/>
-              <a:t>Objects have abilities (methods) they can perform on their own data</a:t>
-            </a:r>
-          </a:p>
-          <a:p>
-            <a:pPr lvl="2"/>
-            <a:endParaRPr lang="en-IE" sz="2800" dirty="0"/>
-          </a:p>
-        </p:txBody>
-      </p:sp>
-    </p:spTree>
-    <p:extLst>
-      <p:ext uri="{BB962C8B-B14F-4D97-AF65-F5344CB8AC3E}">
-        <p14:creationId xmlns:p14="http://schemas.microsoft.com/office/powerpoint/2010/main" val="440946638"/>
-      </p:ext>
-    </p:extLst>
-  </p:cSld>
-  <p:clrMapOvr>
-    <a:masterClrMapping/>
-  </p:clrMapOvr>
-</p:sld>
-</file>
-
-<file path=ppt/slides/slide20.xml><?xml version="1.0" encoding="utf-8"?>
+<file path=ppt/slides/slide22.xml><?xml version="1.0" encoding="utf-8"?>
 <p:sld xmlns:a="http://schemas.openxmlformats.org/drawingml/2006/main" xmlns:r="http://schemas.openxmlformats.org/officeDocument/2006/relationships" xmlns:p="http://schemas.openxmlformats.org/presentationml/2006/main">
   <p:cSld>
     <p:spTree>
@@ -7723,7 +10078,15 @@
           <a:p>
             <a:r>
               <a:rPr lang="en-IE" sz="1700" dirty="0" err="1"/>
-              <a:t>slide_examples.introducing_classes</a:t>
+              <a:t>slide_examples</a:t>
+            </a:r>
+            <a:r>
+              <a:rPr lang="en-IE" sz="1700" dirty="0"/>
+              <a:t>/</a:t>
+            </a:r>
+            <a:r>
+              <a:rPr lang="en-IE" sz="1700" dirty="0" err="1"/>
+              <a:t>introducing_classes</a:t>
             </a:r>
             <a:r>
               <a:rPr lang="en-IE" sz="1700" dirty="0"/>
@@ -7747,7 +10110,7 @@
         <p:spPr>
           <a:xfrm>
             <a:off x="392453" y="6191974"/>
-            <a:ext cx="5124092" cy="328665"/>
+            <a:ext cx="5185962" cy="328665"/>
           </a:xfrm>
           <a:prstGeom prst="roundRect">
             <a:avLst/>
@@ -7775,7 +10138,15 @@
           <a:p>
             <a:r>
               <a:rPr lang="en-IE" sz="1700" dirty="0" err="1"/>
-              <a:t>slide_examples.introducing_classes</a:t>
+              <a:t>slide_examples</a:t>
+            </a:r>
+            <a:r>
+              <a:rPr lang="en-IE" sz="1700" dirty="0"/>
+              <a:t>/</a:t>
+            </a:r>
+            <a:r>
+              <a:rPr lang="en-IE" sz="1700" dirty="0" err="1"/>
+              <a:t>introducing_classes</a:t>
             </a:r>
             <a:r>
               <a:rPr lang="en-IE" sz="1700" dirty="0"/>
@@ -9793,4 +12164,319 @@
     </a:ext>
   </a:extLst>
 </a:theme>
+</file>
+
+<file path=ppt/theme/theme2.xml><?xml version="1.0" encoding="utf-8"?>
+<a:theme xmlns:a="http://schemas.openxmlformats.org/drawingml/2006/main" name="Office Theme">
+  <a:themeElements>
+    <a:clrScheme name="Office">
+      <a:dk1>
+        <a:sysClr val="windowText" lastClr="000000"/>
+      </a:dk1>
+      <a:lt1>
+        <a:sysClr val="window" lastClr="FFFFFF"/>
+      </a:lt1>
+      <a:dk2>
+        <a:srgbClr val="0E2841"/>
+      </a:dk2>
+      <a:lt2>
+        <a:srgbClr val="E8E8E8"/>
+      </a:lt2>
+      <a:accent1>
+        <a:srgbClr val="156082"/>
+      </a:accent1>
+      <a:accent2>
+        <a:srgbClr val="E97132"/>
+      </a:accent2>
+      <a:accent3>
+        <a:srgbClr val="196B24"/>
+      </a:accent3>
+      <a:accent4>
+        <a:srgbClr val="0F9ED5"/>
+      </a:accent4>
+      <a:accent5>
+        <a:srgbClr val="A02B93"/>
+      </a:accent5>
+      <a:accent6>
+        <a:srgbClr val="4EA72E"/>
+      </a:accent6>
+      <a:hlink>
+        <a:srgbClr val="467886"/>
+      </a:hlink>
+      <a:folHlink>
+        <a:srgbClr val="96607D"/>
+      </a:folHlink>
+    </a:clrScheme>
+    <a:fontScheme name="Office">
+      <a:majorFont>
+        <a:latin typeface="Aptos Display" panose="02110004020202020204"/>
+        <a:ea typeface=""/>
+        <a:cs typeface=""/>
+        <a:font script="Jpan" typeface="游ゴシック Light"/>
+        <a:font script="Hang" typeface="맑은 고딕"/>
+        <a:font script="Hans" typeface="等线 Light"/>
+        <a:font script="Hant" typeface="新細明體"/>
+        <a:font script="Arab" typeface="Times New Roman"/>
+        <a:font script="Hebr" typeface="Times New Roman"/>
+        <a:font script="Thai" typeface="Angsana New"/>
+        <a:font script="Ethi" typeface="Nyala"/>
+        <a:font script="Beng" typeface="Vrinda"/>
+        <a:font script="Gujr" typeface="Shruti"/>
+        <a:font script="Khmr" typeface="MoolBoran"/>
+        <a:font script="Knda" typeface="Tunga"/>
+        <a:font script="Guru" typeface="Raavi"/>
+        <a:font script="Cans" typeface="Euphemia"/>
+        <a:font script="Cher" typeface="Plantagenet Cherokee"/>
+        <a:font script="Yiii" typeface="Microsoft Yi Baiti"/>
+        <a:font script="Tibt" typeface="Microsoft Himalaya"/>
+        <a:font script="Thaa" typeface="MV Boli"/>
+        <a:font script="Deva" typeface="Mangal"/>
+        <a:font script="Telu" typeface="Gautami"/>
+        <a:font script="Taml" typeface="Latha"/>
+        <a:font script="Syrc" typeface="Estrangelo Edessa"/>
+        <a:font script="Orya" typeface="Kalinga"/>
+        <a:font script="Mlym" typeface="Kartika"/>
+        <a:font script="Laoo" typeface="DokChampa"/>
+        <a:font script="Sinh" typeface="Iskoola Pota"/>
+        <a:font script="Mong" typeface="Mongolian Baiti"/>
+        <a:font script="Viet" typeface="Times New Roman"/>
+        <a:font script="Uigh" typeface="Microsoft Uighur"/>
+        <a:font script="Geor" typeface="Sylfaen"/>
+        <a:font script="Armn" typeface="Arial"/>
+        <a:font script="Bugi" typeface="Leelawadee UI"/>
+        <a:font script="Bopo" typeface="Microsoft JhengHei"/>
+        <a:font script="Java" typeface="Javanese Text"/>
+        <a:font script="Lisu" typeface="Segoe UI"/>
+        <a:font script="Mymr" typeface="Myanmar Text"/>
+        <a:font script="Nkoo" typeface="Ebrima"/>
+        <a:font script="Olck" typeface="Nirmala UI"/>
+        <a:font script="Osma" typeface="Ebrima"/>
+        <a:font script="Phag" typeface="Phagspa"/>
+        <a:font script="Syrn" typeface="Estrangelo Edessa"/>
+        <a:font script="Syrj" typeface="Estrangelo Edessa"/>
+        <a:font script="Syre" typeface="Estrangelo Edessa"/>
+        <a:font script="Sora" typeface="Nirmala UI"/>
+        <a:font script="Tale" typeface="Microsoft Tai Le"/>
+        <a:font script="Talu" typeface="Microsoft New Tai Lue"/>
+        <a:font script="Tfng" typeface="Ebrima"/>
+      </a:majorFont>
+      <a:minorFont>
+        <a:latin typeface="Aptos" panose="02110004020202020204"/>
+        <a:ea typeface=""/>
+        <a:cs typeface=""/>
+        <a:font script="Jpan" typeface="游ゴシック"/>
+        <a:font script="Hang" typeface="맑은 고딕"/>
+        <a:font script="Hans" typeface="等线"/>
+        <a:font script="Hant" typeface="新細明體"/>
+        <a:font script="Arab" typeface="Arial"/>
+        <a:font script="Hebr" typeface="Arial"/>
+        <a:font script="Thai" typeface="Cordia New"/>
+        <a:font script="Ethi" typeface="Nyala"/>
+        <a:font script="Beng" typeface="Vrinda"/>
+        <a:font script="Gujr" typeface="Shruti"/>
+        <a:font script="Khmr" typeface="DaunPenh"/>
+        <a:font script="Knda" typeface="Tunga"/>
+        <a:font script="Guru" typeface="Raavi"/>
+        <a:font script="Cans" typeface="Euphemia"/>
+        <a:font script="Cher" typeface="Plantagenet Cherokee"/>
+        <a:font script="Yiii" typeface="Microsoft Yi Baiti"/>
+        <a:font script="Tibt" typeface="Microsoft Himalaya"/>
+        <a:font script="Thaa" typeface="MV Boli"/>
+        <a:font script="Deva" typeface="Mangal"/>
+        <a:font script="Telu" typeface="Gautami"/>
+        <a:font script="Taml" typeface="Latha"/>
+        <a:font script="Syrc" typeface="Estrangelo Edessa"/>
+        <a:font script="Orya" typeface="Kalinga"/>
+        <a:font script="Mlym" typeface="Kartika"/>
+        <a:font script="Laoo" typeface="DokChampa"/>
+        <a:font script="Sinh" typeface="Iskoola Pota"/>
+        <a:font script="Mong" typeface="Mongolian Baiti"/>
+        <a:font script="Viet" typeface="Arial"/>
+        <a:font script="Uigh" typeface="Microsoft Uighur"/>
+        <a:font script="Geor" typeface="Sylfaen"/>
+        <a:font script="Armn" typeface="Arial"/>
+        <a:font script="Bugi" typeface="Leelawadee UI"/>
+        <a:font script="Bopo" typeface="Microsoft JhengHei"/>
+        <a:font script="Java" typeface="Javanese Text"/>
+        <a:font script="Lisu" typeface="Segoe UI"/>
+        <a:font script="Mymr" typeface="Myanmar Text"/>
+        <a:font script="Nkoo" typeface="Ebrima"/>
+        <a:font script="Olck" typeface="Nirmala UI"/>
+        <a:font script="Osma" typeface="Ebrima"/>
+        <a:font script="Phag" typeface="Phagspa"/>
+        <a:font script="Syrn" typeface="Estrangelo Edessa"/>
+        <a:font script="Syrj" typeface="Estrangelo Edessa"/>
+        <a:font script="Syre" typeface="Estrangelo Edessa"/>
+        <a:font script="Sora" typeface="Nirmala UI"/>
+        <a:font script="Tale" typeface="Microsoft Tai Le"/>
+        <a:font script="Talu" typeface="Microsoft New Tai Lue"/>
+        <a:font script="Tfng" typeface="Ebrima"/>
+      </a:minorFont>
+    </a:fontScheme>
+    <a:fmtScheme name="Office">
+      <a:fillStyleLst>
+        <a:solidFill>
+          <a:schemeClr val="phClr"/>
+        </a:solidFill>
+        <a:gradFill rotWithShape="1">
+          <a:gsLst>
+            <a:gs pos="0">
+              <a:schemeClr val="phClr">
+                <a:lumMod val="110000"/>
+                <a:satMod val="105000"/>
+                <a:tint val="67000"/>
+              </a:schemeClr>
+            </a:gs>
+            <a:gs pos="50000">
+              <a:schemeClr val="phClr">
+                <a:lumMod val="105000"/>
+                <a:satMod val="103000"/>
+                <a:tint val="73000"/>
+              </a:schemeClr>
+            </a:gs>
+            <a:gs pos="100000">
+              <a:schemeClr val="phClr">
+                <a:lumMod val="105000"/>
+                <a:satMod val="109000"/>
+                <a:tint val="81000"/>
+              </a:schemeClr>
+            </a:gs>
+          </a:gsLst>
+          <a:lin ang="5400000" scaled="0"/>
+        </a:gradFill>
+        <a:gradFill rotWithShape="1">
+          <a:gsLst>
+            <a:gs pos="0">
+              <a:schemeClr val="phClr">
+                <a:satMod val="103000"/>
+                <a:lumMod val="102000"/>
+                <a:tint val="94000"/>
+              </a:schemeClr>
+            </a:gs>
+            <a:gs pos="50000">
+              <a:schemeClr val="phClr">
+                <a:satMod val="110000"/>
+                <a:lumMod val="100000"/>
+                <a:shade val="100000"/>
+              </a:schemeClr>
+            </a:gs>
+            <a:gs pos="100000">
+              <a:schemeClr val="phClr">
+                <a:lumMod val="99000"/>
+                <a:satMod val="120000"/>
+                <a:shade val="78000"/>
+              </a:schemeClr>
+            </a:gs>
+          </a:gsLst>
+          <a:lin ang="5400000" scaled="0"/>
+        </a:gradFill>
+      </a:fillStyleLst>
+      <a:lnStyleLst>
+        <a:ln w="12700" cap="flat" cmpd="sng" algn="ctr">
+          <a:solidFill>
+            <a:schemeClr val="phClr"/>
+          </a:solidFill>
+          <a:prstDash val="solid"/>
+          <a:miter lim="800000"/>
+        </a:ln>
+        <a:ln w="19050" cap="flat" cmpd="sng" algn="ctr">
+          <a:solidFill>
+            <a:schemeClr val="phClr"/>
+          </a:solidFill>
+          <a:prstDash val="solid"/>
+          <a:miter lim="800000"/>
+        </a:ln>
+        <a:ln w="25400" cap="flat" cmpd="sng" algn="ctr">
+          <a:solidFill>
+            <a:schemeClr val="phClr"/>
+          </a:solidFill>
+          <a:prstDash val="solid"/>
+          <a:miter lim="800000"/>
+        </a:ln>
+      </a:lnStyleLst>
+      <a:effectStyleLst>
+        <a:effectStyle>
+          <a:effectLst/>
+        </a:effectStyle>
+        <a:effectStyle>
+          <a:effectLst/>
+        </a:effectStyle>
+        <a:effectStyle>
+          <a:effectLst>
+            <a:outerShdw blurRad="57150" dist="19050" dir="5400000" algn="ctr" rotWithShape="0">
+              <a:srgbClr val="000000">
+                <a:alpha val="63000"/>
+              </a:srgbClr>
+            </a:outerShdw>
+          </a:effectLst>
+        </a:effectStyle>
+      </a:effectStyleLst>
+      <a:bgFillStyleLst>
+        <a:solidFill>
+          <a:schemeClr val="phClr"/>
+        </a:solidFill>
+        <a:solidFill>
+          <a:schemeClr val="phClr">
+            <a:tint val="95000"/>
+            <a:satMod val="170000"/>
+          </a:schemeClr>
+        </a:solidFill>
+        <a:gradFill rotWithShape="1">
+          <a:gsLst>
+            <a:gs pos="0">
+              <a:schemeClr val="phClr">
+                <a:tint val="93000"/>
+                <a:satMod val="150000"/>
+                <a:shade val="98000"/>
+                <a:lumMod val="102000"/>
+              </a:schemeClr>
+            </a:gs>
+            <a:gs pos="50000">
+              <a:schemeClr val="phClr">
+                <a:tint val="98000"/>
+                <a:satMod val="130000"/>
+                <a:shade val="90000"/>
+                <a:lumMod val="103000"/>
+              </a:schemeClr>
+            </a:gs>
+            <a:gs pos="100000">
+              <a:schemeClr val="phClr">
+                <a:shade val="63000"/>
+                <a:satMod val="120000"/>
+              </a:schemeClr>
+            </a:gs>
+          </a:gsLst>
+          <a:lin ang="5400000" scaled="0"/>
+        </a:gradFill>
+      </a:bgFillStyleLst>
+    </a:fmtScheme>
+  </a:themeElements>
+  <a:objectDefaults>
+    <a:lnDef>
+      <a:spPr/>
+      <a:bodyPr/>
+      <a:lstStyle/>
+      <a:style>
+        <a:lnRef idx="2">
+          <a:schemeClr val="accent1"/>
+        </a:lnRef>
+        <a:fillRef idx="0">
+          <a:schemeClr val="accent1"/>
+        </a:fillRef>
+        <a:effectRef idx="1">
+          <a:schemeClr val="accent1"/>
+        </a:effectRef>
+        <a:fontRef idx="minor">
+          <a:schemeClr val="tx1"/>
+        </a:fontRef>
+      </a:style>
+    </a:lnDef>
+  </a:objectDefaults>
+  <a:extraClrSchemeLst/>
+  <a:extLst>
+    <a:ext uri="{05A4C25C-085E-4340-85A3-A5531E510DB2}">
+      <thm15:themeFamily xmlns:thm15="http://schemas.microsoft.com/office/thememl/2012/main" name="Office Theme" id="{2E142A2C-CD16-42D6-873A-C26D2A0506FA}" vid="{1BDDFF52-6CD6-40A5-AB3C-68EB2F1E4D0A}"/>
+    </a:ext>
+  </a:extLst>
+</a:theme>
 </file>
</xml_diff>